<commit_message>
feat(ppt): 查询层切换为 Databricks Serverless（方案 B → B2）
- 应用架构图：READ PATH 的 Trino → Databricks Serverless（SQL Warehouse），
  rules.json 授权 → Unity Catalog 表级授权，安全底座改为 Databricks
  Query History，取舍说明改为 B2（托管 / 引擎绑定 / Premium 前提）
- 湖仓一体存算分离图：B-04 读侧卡改为 SQL Warehouse（Serverless ·
  零运维 · UC 授权 · X-Small 6 DBU/h · 空闲缩 0），边界箭头标签改为
  Serverless 直查；成本结构、要点、取舍卡同步更新
- 封面与页内标题统一为「方案 B2」

Co-authored-by: arena-agent <297053741+arena-agent@users.noreply.github.com>
</commit_message>
<xml_diff>
--- a/report/方案B_B2_架构图集.pptx
+++ b/report/方案B_B2_架构图集.pptx
@@ -3771,7 +3771,7 @@
                 <a:latin typeface="Segoe UI"/>
                 <a:ea typeface="Microsoft YaHei"/>
               </a:rPr>
-              <a:t>读侧 · Trino</a:t>
+              <a:t>读侧 · Serverless</a:t>
             </a:r>
           </a:p>
         </p:txBody>
@@ -4550,7 +4550,7 @@
                 <a:latin typeface="Segoe UI"/>
                 <a:ea typeface="Microsoft YaHei"/>
               </a:rPr>
-              <a:t>应用架构图 · 方案 B（湖仓一体 + Trino 读）</a:t>
+              <a:t>应用架构图 · 方案 B2（湖仓一体 · Databricks Serverless 读）</a:t>
             </a:r>
           </a:p>
         </p:txBody>
@@ -4790,7 +4790,7 @@
                 <a:latin typeface="Segoe UI"/>
                 <a:ea typeface="Microsoft YaHei"/>
               </a:rPr>
-              <a:t>方案 B · 湖仓一体 · 存算分离架构</a:t>
+              <a:t>方案 B2 · 湖仓一体 · 存算分离架构</a:t>
             </a:r>
           </a:p>
         </p:txBody>
@@ -4836,7 +4836,7 @@
                 <a:latin typeface="Segoe UI"/>
                 <a:ea typeface="Microsoft YaHei"/>
               </a:rPr>
-              <a:t>源系统 → 接入配置 → 抽取 → Iceberg 冷湖 → 统一计算层 → 消费入口 + 销毁回路</a:t>
+              <a:t>源系统 → 接入配置 → 抽取 → Iceberg 冷湖 → Databricks 读写一体计算层 → 消费入口 + 销毁回路</a:t>
             </a:r>
           </a:p>
         </p:txBody>
@@ -15164,7 +15164,7 @@
                 <a:latin typeface="Segoe UI"/>
                 <a:ea typeface="Microsoft YaHei"/>
               </a:rPr>
-              <a:t>应用架构图 · 方案 B（湖仓一体 + Trino 读）</a:t>
+              <a:t>应用架构图 · 方案 B2（湖仓一体 · Databricks Serverless 读）</a:t>
             </a:r>
           </a:p>
         </p:txBody>
@@ -15210,7 +15210,7 @@
                 <a:latin typeface="Segoe UI"/>
                 <a:ea typeface="Microsoft YaHei"/>
               </a:rPr>
-              <a:t>应用逻辑分层视角 · 与基础设施部署拓扑互补</a:t>
+              <a:t>应用逻辑分层视角 · 读侧 SQL Warehouse · 与基础设施部署拓扑互补</a:t>
             </a:r>
           </a:p>
         </p:txBody>
@@ -17857,7 +17857,7 @@
                 <a:latin typeface="Segoe UI"/>
                 <a:ea typeface="Microsoft YaHei"/>
               </a:rPr>
-              <a:t>Trino</a:t>
+              <a:t>Databricks Serverless</a:t>
             </a:r>
           </a:p>
           <a:p>
@@ -17880,7 +17880,7 @@
                 <a:latin typeface="Segoe UI"/>
                 <a:ea typeface="Microsoft YaHei"/>
               </a:rPr>
-              <a:t>MPP 查询引擎</a:t>
+              <a:t>SQL Warehouse 查询</a:t>
             </a:r>
           </a:p>
         </p:txBody>
@@ -17997,7 +17997,7 @@
                 <a:latin typeface="Segoe UI"/>
                 <a:ea typeface="Microsoft YaHei"/>
               </a:rPr>
-              <a:t>rules.json 表级授权 · SERVE 层首屏 2–5 s</a:t>
+              <a:t>Unity Catalog 表级授权 · SERVE 层首屏 2–5 s</a:t>
             </a:r>
           </a:p>
         </p:txBody>
@@ -19613,7 +19613,7 @@
                 <a:latin typeface="Segoe UI"/>
                 <a:ea typeface="Microsoft YaHei"/>
               </a:rPr>
-              <a:t>Key Vault · App Insights · Azure Monitor · Trino Query History · 全部 PaaS 私有端点 · 入口 WAF</a:t>
+              <a:t>Key Vault · App Insights · Azure Monitor · Databricks Query History · 全部 PaaS 私有端点 · 入口 WAF</a:t>
             </a:r>
           </a:p>
         </p:txBody>
@@ -19707,7 +19707,7 @@
                 <a:latin typeface="Segoe UI"/>
                 <a:ea typeface="Microsoft YaHei"/>
               </a:rPr>
-              <a:t>B 的取舍：</a:t>
+              <a:t>B2 读侧：</a:t>
             </a:r>
             <a:r>
               <a:rPr sz="680" b="0" i="0">
@@ -19717,7 +19717,7 @@
                 <a:latin typeface="Segoe UI"/>
                 <a:ea typeface="Microsoft YaHei"/>
               </a:rPr>
-              <a:t>引擎中立，但需自运维 Trino；列级脱敏不能直接用 UC</a:t>
+              <a:t>SQL Serverless 完全托管 · 空闲缩 0；代价是引擎绑定 + 需 Premium 层（NCC / 私有端点）</a:t>
             </a:r>
           </a:p>
         </p:txBody>
@@ -20285,7 +20285,7 @@
                 <a:latin typeface="Segoe UI"/>
                 <a:ea typeface="Microsoft YaHei"/>
               </a:rPr>
-              <a:t>方案 B · 湖仓一体 · 存算分离架构</a:t>
+              <a:t>方案 B2 · 湖仓一体 · 存算分离架构</a:t>
             </a:r>
           </a:p>
         </p:txBody>
@@ -20331,7 +20331,7 @@
                 <a:latin typeface="Segoe UI"/>
                 <a:ea typeface="Microsoft YaHei"/>
               </a:rPr>
-              <a:t>对象存储冷湖（Iceberg）· Databricks 写侧 + Trino 读侧 · PB 级从容</a:t>
+              <a:t>对象存储冷湖（Iceberg）· Databricks 写读一体（Serverless）· PB 级从容</a:t>
             </a:r>
           </a:p>
         </p:txBody>
@@ -23804,7 +23804,7 @@
                 <a:latin typeface="Segoe UI"/>
                 <a:ea typeface="Microsoft YaHei"/>
               </a:rPr>
-              <a:t>　热表物化 · Z-Order · 供 Trino 直接查询</a:t>
+              <a:t>　热表物化 · Z-Order · 供 SQL Warehouse 直接查询</a:t>
             </a:r>
           </a:p>
         </p:txBody>
@@ -23990,7 +23990,7 @@
                 <a:latin typeface="Segoe UI"/>
                 <a:ea typeface="Microsoft YaHei"/>
               </a:rPr>
-              <a:t>Trino 外表直查</a:t>
+              <a:t>Serverless 直查</a:t>
             </a:r>
           </a:p>
         </p:txBody>
@@ -24337,7 +24337,7 @@
                 <a:latin typeface="Segoe UI"/>
                 <a:ea typeface="Microsoft YaHei"/>
               </a:rPr>
-              <a:t>写侧 · 读侧并列</a:t>
+              <a:t>Databricks 读写一体</a:t>
             </a:r>
           </a:p>
         </p:txBody>
@@ -24847,7 +24847,7 @@
                 <a:latin typeface="Segoe UI"/>
                 <a:ea typeface="Microsoft YaHei"/>
               </a:rPr>
-              <a:t>Trino · 读侧查询引擎</a:t>
+              <a:t>SQL Warehouse · 读侧查询</a:t>
             </a:r>
           </a:p>
         </p:txBody>
@@ -24893,7 +24893,7 @@
                 <a:latin typeface="Segoe UI"/>
                 <a:ea typeface="Microsoft YaHei"/>
               </a:rPr>
-              <a:t>Iceberg 外表 · MPP 分布式</a:t>
+              <a:t>Serverless · 零运维 · 故障自动重建</a:t>
             </a:r>
           </a:p>
         </p:txBody>
@@ -24939,7 +24939,7 @@
                 <a:latin typeface="Segoe UI"/>
                 <a:ea typeface="Microsoft YaHei"/>
               </a:rPr>
-              <a:t>首屏 2–5 s · SERVE 层加速</a:t>
+              <a:t>Iceberg 直查 · SERVE 加速 · 首屏 2–5 s</a:t>
             </a:r>
           </a:p>
         </p:txBody>
@@ -24985,7 +24985,7 @@
                 <a:latin typeface="Segoe UI"/>
                 <a:ea typeface="Microsoft YaHei"/>
               </a:rPr>
-              <a:t>RLS 行级权限 · 查询网关</a:t>
+              <a:t>UC 表 / 行 / 列级授权 + 审计</a:t>
             </a:r>
           </a:p>
         </p:txBody>
@@ -25031,7 +25031,7 @@
                 <a:latin typeface="Segoe UI"/>
                 <a:ea typeface="Microsoft YaHei"/>
               </a:rPr>
-              <a:t>常驻小集群 · 弹性扩缩 ≈¥0.4–0.6 万/月</a:t>
+              <a:t>X-Small 6 DBU/h · 空闲缩 0 ≈¥0.5–0.9 万/月</a:t>
             </a:r>
           </a:p>
         </p:txBody>
@@ -27683,7 +27683,7 @@
                 <a:latin typeface="Segoe UI"/>
                 <a:ea typeface="Microsoft YaHei"/>
               </a:rPr>
-              <a:t>Databricks ≈¥0.4–0.8 万/月 · Trino ≈¥0.4–0.6 万/月</a:t>
+              <a:t>写侧 Jobs ≈¥0.4–0.8 万/月 · 读侧 Warehouse ≈¥0.5–0.9 万/月</a:t>
             </a:r>
           </a:p>
         </p:txBody>
@@ -27823,7 +27823,7 @@
                 <a:latin typeface="Segoe UI"/>
                 <a:ea typeface="Microsoft YaHei"/>
               </a:rPr>
-              <a:t>方案 B 要点</a:t>
+              <a:t>方案 B2 要点</a:t>
             </a:r>
           </a:p>
         </p:txBody>
@@ -27879,7 +27879,7 @@
                 <a:latin typeface="Segoe UI"/>
                 <a:ea typeface="Microsoft YaHei"/>
               </a:rPr>
-              <a:t>冷湖常驻，Databricks / Trino 按需拉起 · 按量计费</a:t>
+              <a:t>冷湖常驻，Serverless 读写按需拉起 · 空闲缩 0</a:t>
             </a:r>
           </a:p>
         </p:txBody>
@@ -28037,7 +28037,7 @@
                 <a:latin typeface="Segoe UI"/>
                 <a:ea typeface="Microsoft YaHei"/>
               </a:rPr>
-              <a:t>· 与 B2 差异 — </a:t>
+              <a:t>· 读侧托管 — </a:t>
             </a:r>
             <a:r>
               <a:rPr sz="610" b="0" i="0">
@@ -28047,7 +28047,7 @@
                 <a:latin typeface="Segoe UI"/>
                 <a:ea typeface="Microsoft YaHei"/>
               </a:rPr>
-              <a:t>自建 Trino（rules.json 授权）· 引擎中立避免锁定</a:t>
+              <a:t>SQL Warehouse Serverless · 零集群运维 · UC 授权</a:t>
             </a:r>
           </a:p>
         </p:txBody>
@@ -28197,7 +28197,7 @@
                 <a:latin typeface="Segoe UI"/>
                 <a:ea typeface="Microsoft YaHei"/>
               </a:rPr>
-              <a:t>B 的取舍</a:t>
+              <a:t>B2 的取舍</a:t>
             </a:r>
           </a:p>
         </p:txBody>
@@ -28243,7 +28243,7 @@
                 <a:latin typeface="Segoe UI"/>
                 <a:ea typeface="Microsoft YaHei"/>
               </a:rPr>
-              <a:t>引擎中立、无单一厂商锁定；代价是需自运维 Trino 集群（部署 / 升级 / 容量），列级脱敏不能直接用 Unity Catalog。</a:t>
+              <a:t>读侧完全托管、UC 治理原生；代价是计算引擎绑定 Databricks（数据仍为开放 Iceberg，随时可换引擎），且 Serverless / NCC 需 Premium 层。</a:t>
             </a:r>
           </a:p>
         </p:txBody>

</xml_diff>

<commit_message>
docs(ppt): 结构化抽取统一为 Apache SeaTunnel，移除 DataX
技术栈清单、源系统抽取卡、抽取箭头标签三处统一为 SeaTunnel

Co-authored-by: arena-agent <297053741+arena-agent@users.noreply.github.com>
</commit_message>
<xml_diff>
--- a/report/方案B_B2_架构图集.pptx
+++ b/report/方案B_B2_架构图集.pptx
@@ -5442,7 +5442,7 @@
                 <a:latin typeface="Segoe UI"/>
                 <a:ea typeface="Microsoft YaHei"/>
               </a:rPr>
-              <a:t>抽取 · DataX / SeaTunnel</a:t>
+              <a:t>抽取 · Apache SeaTunnel</a:t>
             </a:r>
           </a:p>
         </p:txBody>
@@ -7480,7 +7480,7 @@
                 <a:latin typeface="Segoe UI"/>
                 <a:ea typeface="Microsoft YaHei"/>
               </a:rPr>
-              <a:t>DataX / SeaTunnel</a:t>
+              <a:t>Apache SeaTunnel</a:t>
             </a:r>
           </a:p>
           <a:p>
@@ -11493,7 +11493,7 @@
                 <a:latin typeface="Segoe UI"/>
                 <a:ea typeface="Microsoft YaHei"/>
               </a:rPr>
-              <a:t>DataX / SeaTunnel 抽取 · NAT 固定 IP</a:t>
+              <a:t>SeaTunnel 抽取 · NAT 固定 IP</a:t>
             </a:r>
           </a:p>
         </p:txBody>

</xml_diff>

<commit_message>
docs(ppt): 编排调度统一为 Azure Data Factory，移除 Airflow
技术栈清单、源系统抽取卡、写入链路编排框、湖仓图抽取阶段四处统一为 ADF

Co-authored-by: arena-agent <297053741+arena-agent@users.noreply.github.com>
</commit_message>
<xml_diff>
--- a/report/方案B_B2_架构图集.pptx
+++ b/report/方案B_B2_架构图集.pptx
@@ -5498,7 +5498,7 @@
                 <a:latin typeface="Segoe UI"/>
                 <a:ea typeface="Microsoft YaHei"/>
               </a:rPr>
-              <a:t>编排 · Airflow / ADF</a:t>
+              <a:t>编排 · Azure Data Factory</a:t>
             </a:r>
           </a:p>
         </p:txBody>
@@ -7503,7 +7503,7 @@
                 <a:latin typeface="Segoe UI"/>
                 <a:ea typeface="Microsoft YaHei"/>
               </a:rPr>
-              <a:t>仅读权限 · 按勾选的表抽取（10 选 5）· Airflow / ADF 编排</a:t>
+              <a:t>仅读权限 · 按勾选的表抽取（10 选 5）· ADF 编排</a:t>
             </a:r>
           </a:p>
         </p:txBody>
@@ -17231,7 +17231,7 @@
                 <a:latin typeface="Segoe UI"/>
                 <a:ea typeface="Microsoft YaHei"/>
               </a:rPr>
-              <a:t>Airflow / ADF</a:t>
+              <a:t>Azure Data Factory</a:t>
             </a:r>
           </a:p>
           <a:p>
@@ -22485,7 +22485,7 @@
                 <a:latin typeface="Segoe UI"/>
                 <a:ea typeface="Microsoft YaHei"/>
               </a:rPr>
-              <a:t>Airflow / ADF 编排</a:t>
+              <a:t>ADF 编排调度</a:t>
             </a:r>
           </a:p>
         </p:txBody>

</xml_diff>

<commit_message>
docs(ppt): 读侧名称统一为正式产品名 Serverless SQL Warehouse
Co-authored-by: arena-agent <297053741+arena-agent@users.noreply.github.com>
</commit_message>
<xml_diff>
--- a/report/方案B_B2_架构图集.pptx
+++ b/report/方案B_B2_架构图集.pptx
@@ -4550,7 +4550,7 @@
                 <a:latin typeface="Segoe UI"/>
                 <a:ea typeface="Microsoft YaHei"/>
               </a:rPr>
-              <a:t>应用架构图 · 方案 B2（湖仓一体 · Databricks Serverless 读）</a:t>
+              <a:t>应用架构图 · 方案 B2（湖仓一体 · Serverless SQL Warehouse 读）</a:t>
             </a:r>
           </a:p>
         </p:txBody>
@@ -15164,7 +15164,7 @@
                 <a:latin typeface="Segoe UI"/>
                 <a:ea typeface="Microsoft YaHei"/>
               </a:rPr>
-              <a:t>应用架构图 · 方案 B2（湖仓一体 · Databricks Serverless 读）</a:t>
+              <a:t>应用架构图 · 方案 B2（湖仓一体 · Serverless SQL Warehouse 读）</a:t>
             </a:r>
           </a:p>
         </p:txBody>
@@ -17857,7 +17857,7 @@
                 <a:latin typeface="Segoe UI"/>
                 <a:ea typeface="Microsoft YaHei"/>
               </a:rPr>
-              <a:t>Databricks Serverless</a:t>
+              <a:t>Serverless SQL Warehouse</a:t>
             </a:r>
           </a:p>
           <a:p>
@@ -17880,7 +17880,7 @@
                 <a:latin typeface="Segoe UI"/>
                 <a:ea typeface="Microsoft YaHei"/>
               </a:rPr>
-              <a:t>SQL Warehouse 查询</a:t>
+              <a:t>读侧查询 · 空闲缩 0</a:t>
             </a:r>
           </a:p>
         </p:txBody>
@@ -19717,7 +19717,7 @@
                 <a:latin typeface="Segoe UI"/>
                 <a:ea typeface="Microsoft YaHei"/>
               </a:rPr>
-              <a:t>SQL Serverless 完全托管 · 空闲缩 0；代价是引擎绑定 + 需 Premium 层（NCC / 私有端点）</a:t>
+              <a:t>Serverless SQL Warehouse 完全托管 · 空闲缩 0；代价是引擎绑定 + 需 Premium 层（NCC / PE）</a:t>
             </a:r>
           </a:p>
         </p:txBody>
@@ -24847,7 +24847,7 @@
                 <a:latin typeface="Segoe UI"/>
                 <a:ea typeface="Microsoft YaHei"/>
               </a:rPr>
-              <a:t>SQL Warehouse · 读侧查询</a:t>
+              <a:t>Serverless SQL Warehouse</a:t>
             </a:r>
           </a:p>
         </p:txBody>
@@ -24893,7 +24893,7 @@
                 <a:latin typeface="Segoe UI"/>
                 <a:ea typeface="Microsoft YaHei"/>
               </a:rPr>
-              <a:t>Serverless · 零运维 · 故障自动重建</a:t>
+              <a:t>读侧查询 · 零运维 · 故障自动重建</a:t>
             </a:r>
           </a:p>
         </p:txBody>
@@ -28047,7 +28047,7 @@
                 <a:latin typeface="Segoe UI"/>
                 <a:ea typeface="Microsoft YaHei"/>
               </a:rPr>
-              <a:t>SQL Warehouse Serverless · 零集群运维 · UC 授权</a:t>
+              <a:t>Serverless SQL Warehouse · 零集群运维 · UC 授权</a:t>
             </a:r>
           </a:p>
         </p:txBody>

</xml_diff>

<commit_message>
docs(ppt): 计算层命名统一——Serverless Jobs→Databricks Serverless，Serverless SQL Warehouse→Databricks SQL Serverless
Co-authored-by: arena-agent <297053741+arena-agent@users.noreply.github.com>
</commit_message>
<xml_diff>
--- a/report/方案B_B2_架构图集.pptx
+++ b/report/方案B_B2_架构图集.pptx
@@ -4550,7 +4550,7 @@
                 <a:latin typeface="Segoe UI"/>
                 <a:ea typeface="Microsoft YaHei"/>
               </a:rPr>
-              <a:t>应用架构图 · 方案 B2（湖仓一体 · Serverless SQL Warehouse 读）</a:t>
+              <a:t>应用架构图 · 方案 B2（湖仓一体 · Databricks SQL Serverless 读）</a:t>
             </a:r>
           </a:p>
         </p:txBody>
@@ -8680,7 +8680,7 @@
                 <a:latin typeface="Segoe UI"/>
                 <a:ea typeface="Microsoft YaHei"/>
               </a:rPr>
-              <a:t>Serverless SQL Warehouse</a:t>
+              <a:t>Databricks SQL Serverless</a:t>
             </a:r>
           </a:p>
         </p:txBody>
@@ -8998,7 +8998,7 @@
                 <a:latin typeface="Segoe UI"/>
                 <a:ea typeface="Microsoft YaHei"/>
               </a:rPr>
-              <a:t>Serverless Jobs</a:t>
+              <a:t>Databricks Serverless</a:t>
             </a:r>
           </a:p>
         </p:txBody>
@@ -15026,7 +15026,7 @@
                 <a:latin typeface="Segoe UI"/>
                 <a:ea typeface="Microsoft YaHei"/>
               </a:rPr>
-              <a:t>应用架构图 · 方案 B2（湖仓一体 · Serverless SQL Warehouse 读）</a:t>
+              <a:t>应用架构图 · 方案 B2（湖仓一体 · Databricks SQL Serverless 读）</a:t>
             </a:r>
           </a:p>
         </p:txBody>
@@ -15072,7 +15072,7 @@
                 <a:latin typeface="Segoe UI"/>
                 <a:ea typeface="Microsoft YaHei"/>
               </a:rPr>
-              <a:t>应用逻辑分层视角 · 读侧 Serverless SQL Warehouse · 与基础设施拓扑互补</a:t>
+              <a:t>应用逻辑分层视角 · 读侧 Databricks SQL Serverless · 与基础设施拓扑互补</a:t>
             </a:r>
           </a:p>
         </p:txBody>
@@ -17264,7 +17264,7 @@
                 <a:latin typeface="Segoe UI"/>
                 <a:ea typeface="Microsoft YaHei"/>
               </a:rPr>
-              <a:t>Databricks Jobs：ETL · Compaction · DROP PARTITION + VACUUM</a:t>
+              <a:t>Databricks Serverless：ETL · Compaction · DROP PARTITION + VACUUM</a:t>
             </a:r>
           </a:p>
         </p:txBody>
@@ -17627,7 +17627,7 @@
                 <a:latin typeface="Segoe UI"/>
                 <a:ea typeface="Microsoft YaHei"/>
               </a:rPr>
-              <a:t>Serverless SQL Warehouse</a:t>
+              <a:t>Databricks SQL Serverless</a:t>
             </a:r>
           </a:p>
           <a:p>
@@ -19487,7 +19487,7 @@
                 <a:latin typeface="Segoe UI"/>
                 <a:ea typeface="Microsoft YaHei"/>
               </a:rPr>
-              <a:t>Serverless SQL Warehouse 完全托管 · 空闲缩 0；代价是引擎绑定 + 需 Premium 层（NCC / PE）</a:t>
+              <a:t>Databricks SQL Serverless 完全托管 · 空闲缩 0；代价是引擎绑定 + 需 Premium 层（NCC / PE）</a:t>
             </a:r>
           </a:p>
         </p:txBody>
@@ -23436,7 +23436,7 @@
                 <a:latin typeface="Segoe UI"/>
                 <a:ea typeface="Microsoft YaHei"/>
               </a:rPr>
-              <a:t>　热表物化 · Z-Order · 供 SQL Warehouse 直接查询</a:t>
+              <a:t>　热表物化 · Z-Order · 供 Databricks SQL Serverless 直查</a:t>
             </a:r>
           </a:p>
         </p:txBody>
@@ -24387,7 +24387,7 @@
                 <a:latin typeface="Segoe UI"/>
                 <a:ea typeface="Microsoft YaHei"/>
               </a:rPr>
-              <a:t>Serverless SQL Warehouse</a:t>
+              <a:t>Databricks SQL Serverless</a:t>
             </a:r>
           </a:p>
         </p:txBody>
@@ -27223,7 +27223,7 @@
                 <a:latin typeface="Segoe UI"/>
                 <a:ea typeface="Microsoft YaHei"/>
               </a:rPr>
-              <a:t>写侧 Jobs ≈¥0.4–0.8 万/月 · 读侧 Warehouse ≈¥0.5–0.9 万/月</a:t>
+              <a:t>写侧 ETL ≈¥0.4–0.8 万/月 · 读侧查询 ≈¥0.5–0.9 万/月</a:t>
             </a:r>
           </a:p>
         </p:txBody>
@@ -27587,7 +27587,7 @@
                 <a:latin typeface="Segoe UI"/>
                 <a:ea typeface="Microsoft YaHei"/>
               </a:rPr>
-              <a:t>Serverless SQL Warehouse · 零集群运维 · UC 授权</a:t>
+              <a:t>Databricks SQL Serverless · 零集群运维 · UC 授权</a:t>
             </a:r>
           </a:p>
         </p:txBody>

</xml_diff>

<commit_message>
docs(report): 新增 SeaTunnel 约 200 个原生连接器生态页
Co-authored-by: arena-agent <297053741+arena-agent@users.noreply.github.com>
</commit_message>
<xml_diff>
--- a/report/方案B_B2_架构图集.pptx
+++ b/report/方案B_B2_架构图集.pptx
@@ -13,6 +13,7 @@
     <p:sldId id="261" r:id="rId12"/>
     <p:sldId id="262" r:id="rId13"/>
     <p:sldId id="263" r:id="rId14"/>
+    <p:sldId id="264" r:id="rId15"/>
   </p:sldIdLst>
   <p:sldSz cx="12191695" cy="6858000" type="screen4x3"/>
   <p:notesSz cx="6858000" cy="9144000"/>
@@ -5320,7 +5321,7 @@
                 <a:latin typeface="Segoe UI"/>
                 <a:ea typeface="Microsoft YaHei"/>
               </a:rPr>
-              <a:t>抽取入湖分工：普通数据走 SeaTunnel · 敏感 / 加密数据走 Databricks 写侧</a:t>
+              <a:t>抽取入湖分工 + SeaTunnel 约 200 原生连接器生态 · 敏感数据走 Databricks 写侧</a:t>
             </a:r>
           </a:p>
         </p:txBody>
@@ -58715,6 +58716,3562 @@
                 <a:ea typeface="Microsoft YaHei"/>
               </a:rPr>
               <a:t>→ Iceberg 冷湖 · SQL Serverless</a:t>
+            </a:r>
+          </a:p>
+        </p:txBody>
+      </p:sp>
+    </p:spTree>
+  </p:cSld>
+  <p:clrMapOvr>
+    <a:masterClrMapping/>
+  </p:clrMapOvr>
+</p:sld>
+</file>
+
+<file path=ppt/slides/slide9.xml><?xml version="1.0" encoding="utf-8"?>
+<p:sld xmlns:a="http://schemas.openxmlformats.org/drawingml/2006/main" xmlns:p="http://schemas.openxmlformats.org/presentationml/2006/main" xmlns:r="http://schemas.openxmlformats.org/officeDocument/2006/relationships">
+  <p:cSld>
+    <p:bg>
+      <p:bgPr>
+        <a:solidFill>
+          <a:srgbClr val="F8FAFC"/>
+        </a:solidFill>
+        <a:effectLst/>
+      </p:bgPr>
+    </p:bg>
+    <p:spTree>
+      <p:nvGrpSpPr>
+        <p:cNvPr id="1" name=""/>
+        <p:cNvGrpSpPr/>
+        <p:nvPr/>
+      </p:nvGrpSpPr>
+      <p:grpSpPr/>
+      <p:sp>
+        <p:nvSpPr>
+          <p:cNvPr id="2" name="Rounded Rectangle 1"/>
+          <p:cNvSpPr/>
+          <p:nvPr/>
+        </p:nvSpPr>
+        <p:spPr>
+          <a:xfrm>
+            <a:off x="201168" y="155448"/>
+            <a:ext cx="50292" cy="365760"/>
+          </a:xfrm>
+          <a:prstGeom prst="roundRect">
+            <a:avLst>
+              <a:gd name="adj" fmla="val 49090"/>
+            </a:avLst>
+          </a:prstGeom>
+          <a:solidFill>
+            <a:srgbClr val="EA580C"/>
+          </a:solidFill>
+          <a:ln>
+            <a:noFill/>
+          </a:ln>
+          <a:effectLst/>
+        </p:spPr>
+        <p:style>
+          <a:lnRef idx="1">
+            <a:schemeClr val="accent1"/>
+          </a:lnRef>
+          <a:fillRef idx="3">
+            <a:schemeClr val="accent1"/>
+          </a:fillRef>
+          <a:effectRef idx="2">
+            <a:schemeClr val="accent1"/>
+          </a:effectRef>
+          <a:fontRef idx="minor">
+            <a:schemeClr val="lt1"/>
+          </a:fontRef>
+        </p:style>
+        <p:txBody>
+          <a:bodyPr rtlCol="0" anchor="ctr"/>
+          <a:lstStyle/>
+          <a:p>
+            <a:pPr algn="ctr"/>
+          </a:p>
+        </p:txBody>
+      </p:sp>
+      <p:sp>
+        <p:nvSpPr>
+          <p:cNvPr id="3" name="TextBox 2"/>
+          <p:cNvSpPr txBox="1"/>
+          <p:nvPr/>
+        </p:nvSpPr>
+        <p:spPr>
+          <a:xfrm>
+            <a:off x="347472" y="118872"/>
+            <a:ext cx="8229600" cy="310896"/>
+          </a:xfrm>
+          <a:prstGeom prst="rect">
+            <a:avLst/>
+          </a:prstGeom>
+          <a:noFill/>
+        </p:spPr>
+        <p:txBody>
+          <a:bodyPr wrap="square" lIns="0" rIns="0" tIns="0" bIns="0" anchor="ctr">
+            <a:noAutofit/>
+          </a:bodyPr>
+          <a:lstStyle/>
+          <a:p>
+            <a:pPr algn="l">
+              <a:lnSpc>
+                <a:spcPct val="112000"/>
+              </a:lnSpc>
+              <a:spcBef>
+                <a:spcPts val="0"/>
+              </a:spcBef>
+              <a:spcAft>
+                <a:spcPts val="0"/>
+              </a:spcAft>
+            </a:pPr>
+            <a:r>
+              <a:rPr sz="1850" b="1" i="0">
+                <a:solidFill>
+                  <a:srgbClr val="0F172A"/>
+                </a:solidFill>
+                <a:latin typeface="Segoe UI"/>
+                <a:ea typeface="Microsoft YaHei"/>
+              </a:rPr>
+              <a:t>Apache SeaTunnel · 约 200 个原生连接器</a:t>
+            </a:r>
+          </a:p>
+        </p:txBody>
+      </p:sp>
+      <p:sp>
+        <p:nvSpPr>
+          <p:cNvPr id="4" name="TextBox 3"/>
+          <p:cNvSpPr txBox="1"/>
+          <p:nvPr/>
+        </p:nvSpPr>
+        <p:spPr>
+          <a:xfrm>
+            <a:off x="8595360" y="54864"/>
+            <a:ext cx="2788920" cy="384048"/>
+          </a:xfrm>
+          <a:prstGeom prst="rect">
+            <a:avLst/>
+          </a:prstGeom>
+          <a:noFill/>
+        </p:spPr>
+        <p:txBody>
+          <a:bodyPr wrap="square" lIns="0" rIns="0" tIns="0" bIns="0" anchor="ctr">
+            <a:noAutofit/>
+          </a:bodyPr>
+          <a:lstStyle/>
+          <a:p>
+            <a:pPr algn="r">
+              <a:lnSpc>
+                <a:spcPct val="125000"/>
+              </a:lnSpc>
+              <a:spcBef>
+                <a:spcPts val="0"/>
+              </a:spcBef>
+              <a:spcAft>
+                <a:spcPts val="0"/>
+              </a:spcAft>
+            </a:pPr>
+            <a:r>
+              <a:rPr sz="750" b="0" i="0">
+                <a:solidFill>
+                  <a:srgbClr val="64748B"/>
+                </a:solidFill>
+                <a:latin typeface="Segoe UI"/>
+                <a:ea typeface="Microsoft YaHei"/>
+              </a:rPr>
+              <a:t>数据集成引擎 · 来源 seatunnel.apache.org/zh-CN</a:t>
+            </a:r>
+          </a:p>
+        </p:txBody>
+      </p:sp>
+      <p:sp>
+        <p:nvSpPr>
+          <p:cNvPr id="5" name="Rounded Rectangle 4"/>
+          <p:cNvSpPr/>
+          <p:nvPr/>
+        </p:nvSpPr>
+        <p:spPr>
+          <a:xfrm>
+            <a:off x="201168" y="530352"/>
+            <a:ext cx="11786616" cy="384048"/>
+          </a:xfrm>
+          <a:prstGeom prst="roundRect">
+            <a:avLst>
+              <a:gd name="adj" fmla="val 14285"/>
+            </a:avLst>
+          </a:prstGeom>
+          <a:solidFill>
+            <a:srgbClr val="FFF7ED"/>
+          </a:solidFill>
+          <a:ln w="15240">
+            <a:solidFill>
+              <a:srgbClr val="FDBA74"/>
+            </a:solidFill>
+          </a:ln>
+          <a:effectLst/>
+        </p:spPr>
+        <p:style>
+          <a:lnRef idx="1">
+            <a:schemeClr val="accent1"/>
+          </a:lnRef>
+          <a:fillRef idx="3">
+            <a:schemeClr val="accent1"/>
+          </a:fillRef>
+          <a:effectRef idx="2">
+            <a:schemeClr val="accent1"/>
+          </a:effectRef>
+          <a:fontRef idx="minor">
+            <a:schemeClr val="lt1"/>
+          </a:fontRef>
+        </p:style>
+        <p:txBody>
+          <a:bodyPr rtlCol="0" anchor="ctr"/>
+          <a:lstStyle/>
+          <a:p>
+            <a:pPr algn="ctr"/>
+          </a:p>
+        </p:txBody>
+      </p:sp>
+      <p:sp>
+        <p:nvSpPr>
+          <p:cNvPr id="6" name="TextBox 5"/>
+          <p:cNvSpPr txBox="1"/>
+          <p:nvPr/>
+        </p:nvSpPr>
+        <p:spPr>
+          <a:xfrm>
+            <a:off x="201168" y="530352"/>
+            <a:ext cx="11786616" cy="384048"/>
+          </a:xfrm>
+          <a:prstGeom prst="rect">
+            <a:avLst/>
+          </a:prstGeom>
+          <a:noFill/>
+        </p:spPr>
+        <p:txBody>
+          <a:bodyPr wrap="square" lIns="0" rIns="0" tIns="0" bIns="0" anchor="ctr">
+            <a:noAutofit/>
+          </a:bodyPr>
+          <a:lstStyle/>
+          <a:p>
+            <a:pPr algn="ctr">
+              <a:lnSpc>
+                <a:spcPct val="112000"/>
+              </a:lnSpc>
+              <a:spcBef>
+                <a:spcPts val="0"/>
+              </a:spcBef>
+              <a:spcAft>
+                <a:spcPts val="0"/>
+              </a:spcAft>
+            </a:pPr>
+            <a:r>
+              <a:rPr sz="819" b="1" i="0">
+                <a:solidFill>
+                  <a:srgbClr val="C2410C"/>
+                </a:solidFill>
+                <a:latin typeface="Segoe UI"/>
+                <a:ea typeface="Microsoft YaHei"/>
+              </a:rPr>
+              <a:t>只要你的数据在那里，SeaTunnel 就能连接 —— 覆盖数据库 · 消息系统 · 湖仓 · 搜索系统 · 对象存储等主流数据系统</a:t>
+            </a:r>
+          </a:p>
+        </p:txBody>
+      </p:sp>
+      <p:sp>
+        <p:nvSpPr>
+          <p:cNvPr id="7" name="Rounded Rectangle 6"/>
+          <p:cNvSpPr/>
+          <p:nvPr/>
+        </p:nvSpPr>
+        <p:spPr>
+          <a:xfrm>
+            <a:off x="201168" y="1005840"/>
+            <a:ext cx="5760720" cy="1572768"/>
+          </a:xfrm>
+          <a:prstGeom prst="roundRect">
+            <a:avLst>
+              <a:gd name="adj" fmla="val 4069"/>
+            </a:avLst>
+          </a:prstGeom>
+          <a:solidFill>
+            <a:srgbClr val="EFF6FF"/>
+          </a:solidFill>
+          <a:ln w="15240">
+            <a:solidFill>
+              <a:srgbClr val="BFDBFE"/>
+            </a:solidFill>
+          </a:ln>
+          <a:effectLst/>
+        </p:spPr>
+        <p:style>
+          <a:lnRef idx="1">
+            <a:schemeClr val="accent1"/>
+          </a:lnRef>
+          <a:fillRef idx="3">
+            <a:schemeClr val="accent1"/>
+          </a:fillRef>
+          <a:effectRef idx="2">
+            <a:schemeClr val="accent1"/>
+          </a:effectRef>
+          <a:fontRef idx="minor">
+            <a:schemeClr val="lt1"/>
+          </a:fontRef>
+        </p:style>
+        <p:txBody>
+          <a:bodyPr rtlCol="0" anchor="ctr"/>
+          <a:lstStyle/>
+          <a:p>
+            <a:pPr algn="ctr"/>
+          </a:p>
+        </p:txBody>
+      </p:sp>
+      <p:sp>
+        <p:nvSpPr>
+          <p:cNvPr id="8" name="Rounded Rectangle 7"/>
+          <p:cNvSpPr/>
+          <p:nvPr/>
+        </p:nvSpPr>
+        <p:spPr>
+          <a:xfrm>
+            <a:off x="201168" y="1005840"/>
+            <a:ext cx="36576" cy="1572768"/>
+          </a:xfrm>
+          <a:prstGeom prst="roundRect">
+            <a:avLst>
+              <a:gd name="adj" fmla="val 50000"/>
+            </a:avLst>
+          </a:prstGeom>
+          <a:solidFill>
+            <a:srgbClr val="0078D4"/>
+          </a:solidFill>
+          <a:ln>
+            <a:noFill/>
+          </a:ln>
+          <a:effectLst/>
+        </p:spPr>
+        <p:style>
+          <a:lnRef idx="1">
+            <a:schemeClr val="accent1"/>
+          </a:lnRef>
+          <a:fillRef idx="3">
+            <a:schemeClr val="accent1"/>
+          </a:fillRef>
+          <a:effectRef idx="2">
+            <a:schemeClr val="accent1"/>
+          </a:effectRef>
+          <a:fontRef idx="minor">
+            <a:schemeClr val="lt1"/>
+          </a:fontRef>
+        </p:style>
+        <p:txBody>
+          <a:bodyPr rtlCol="0" anchor="ctr"/>
+          <a:lstStyle/>
+          <a:p>
+            <a:pPr algn="ctr"/>
+          </a:p>
+        </p:txBody>
+      </p:sp>
+      <p:sp>
+        <p:nvSpPr>
+          <p:cNvPr id="9" name="TextBox 8"/>
+          <p:cNvSpPr txBox="1"/>
+          <p:nvPr/>
+        </p:nvSpPr>
+        <p:spPr>
+          <a:xfrm>
+            <a:off x="347472" y="1097280"/>
+            <a:ext cx="5468112" cy="219456"/>
+          </a:xfrm>
+          <a:prstGeom prst="rect">
+            <a:avLst/>
+          </a:prstGeom>
+          <a:noFill/>
+        </p:spPr>
+        <p:txBody>
+          <a:bodyPr wrap="square" lIns="0" rIns="0" tIns="0" bIns="0" anchor="t">
+            <a:noAutofit/>
+          </a:bodyPr>
+          <a:lstStyle/>
+          <a:p>
+            <a:pPr algn="l">
+              <a:lnSpc>
+                <a:spcPct val="112000"/>
+              </a:lnSpc>
+              <a:spcBef>
+                <a:spcPts val="0"/>
+              </a:spcBef>
+              <a:spcAft>
+                <a:spcPts val="0"/>
+              </a:spcAft>
+            </a:pPr>
+            <a:r>
+              <a:rPr sz="940" b="1" i="0">
+                <a:solidFill>
+                  <a:srgbClr val="0F172A"/>
+                </a:solidFill>
+                <a:latin typeface="Segoe UI"/>
+                <a:ea typeface="Microsoft YaHei"/>
+              </a:rPr>
+              <a:t>OLTP 数据库</a:t>
+            </a:r>
+          </a:p>
+        </p:txBody>
+      </p:sp>
+      <p:sp>
+        <p:nvSpPr>
+          <p:cNvPr id="10" name="TextBox 9"/>
+          <p:cNvSpPr txBox="1"/>
+          <p:nvPr/>
+        </p:nvSpPr>
+        <p:spPr>
+          <a:xfrm>
+            <a:off x="347472" y="1325880"/>
+            <a:ext cx="5468112" cy="137160"/>
+          </a:xfrm>
+          <a:prstGeom prst="rect">
+            <a:avLst/>
+          </a:prstGeom>
+          <a:noFill/>
+        </p:spPr>
+        <p:txBody>
+          <a:bodyPr wrap="square" lIns="0" rIns="0" tIns="0" bIns="0" anchor="t">
+            <a:noAutofit/>
+          </a:bodyPr>
+          <a:lstStyle/>
+          <a:p>
+            <a:pPr algn="l">
+              <a:lnSpc>
+                <a:spcPct val="112000"/>
+              </a:lnSpc>
+              <a:spcBef>
+                <a:spcPts val="0"/>
+              </a:spcBef>
+              <a:spcAft>
+                <a:spcPts val="0"/>
+              </a:spcAft>
+            </a:pPr>
+            <a:r>
+              <a:rPr sz="620" b="1" i="0">
+                <a:solidFill>
+                  <a:srgbClr val="0078D4"/>
+                </a:solidFill>
+                <a:latin typeface="Segoe UI"/>
+                <a:ea typeface="Microsoft YaHei"/>
+              </a:rPr>
+              <a:t>关系型 · +25 via JDBC</a:t>
+            </a:r>
+          </a:p>
+        </p:txBody>
+      </p:sp>
+      <p:sp>
+        <p:nvSpPr>
+          <p:cNvPr id="11" name="Rounded Rectangle 10"/>
+          <p:cNvSpPr/>
+          <p:nvPr/>
+        </p:nvSpPr>
+        <p:spPr>
+          <a:xfrm>
+            <a:off x="347472" y="1527048"/>
+            <a:ext cx="1761743" cy="420624"/>
+          </a:xfrm>
+          <a:prstGeom prst="roundRect">
+            <a:avLst>
+              <a:gd name="adj" fmla="val 10869"/>
+            </a:avLst>
+          </a:prstGeom>
+          <a:solidFill>
+            <a:srgbClr val="FFFFFF"/>
+          </a:solidFill>
+          <a:ln w="12700">
+            <a:solidFill>
+              <a:srgbClr val="BFDBFE"/>
+            </a:solidFill>
+          </a:ln>
+          <a:effectLst/>
+        </p:spPr>
+        <p:style>
+          <a:lnRef idx="1">
+            <a:schemeClr val="accent1"/>
+          </a:lnRef>
+          <a:fillRef idx="3">
+            <a:schemeClr val="accent1"/>
+          </a:fillRef>
+          <a:effectRef idx="2">
+            <a:schemeClr val="accent1"/>
+          </a:effectRef>
+          <a:fontRef idx="minor">
+            <a:schemeClr val="lt1"/>
+          </a:fontRef>
+        </p:style>
+        <p:txBody>
+          <a:bodyPr rtlCol="0" anchor="ctr"/>
+          <a:lstStyle/>
+          <a:p>
+            <a:pPr algn="ctr"/>
+          </a:p>
+        </p:txBody>
+      </p:sp>
+      <p:sp>
+        <p:nvSpPr>
+          <p:cNvPr id="12" name="TextBox 11"/>
+          <p:cNvSpPr txBox="1"/>
+          <p:nvPr/>
+        </p:nvSpPr>
+        <p:spPr>
+          <a:xfrm>
+            <a:off x="347472" y="1527048"/>
+            <a:ext cx="1761743" cy="420624"/>
+          </a:xfrm>
+          <a:prstGeom prst="rect">
+            <a:avLst/>
+          </a:prstGeom>
+          <a:noFill/>
+        </p:spPr>
+        <p:txBody>
+          <a:bodyPr wrap="square" lIns="0" rIns="0" tIns="0" bIns="0" anchor="ctr">
+            <a:noAutofit/>
+          </a:bodyPr>
+          <a:lstStyle/>
+          <a:p>
+            <a:pPr algn="ctr">
+              <a:lnSpc>
+                <a:spcPct val="112000"/>
+              </a:lnSpc>
+              <a:spcBef>
+                <a:spcPts val="0"/>
+              </a:spcBef>
+              <a:spcAft>
+                <a:spcPts val="0"/>
+              </a:spcAft>
+            </a:pPr>
+            <a:r>
+              <a:rPr sz="620" b="0" i="0">
+                <a:solidFill>
+                  <a:srgbClr val="475569"/>
+                </a:solidFill>
+                <a:latin typeface="Segoe UI"/>
+                <a:ea typeface="Microsoft YaHei"/>
+              </a:rPr>
+              <a:t>MySQL / CDC</a:t>
+            </a:r>
+          </a:p>
+        </p:txBody>
+      </p:sp>
+      <p:sp>
+        <p:nvSpPr>
+          <p:cNvPr id="13" name="Rounded Rectangle 12"/>
+          <p:cNvSpPr/>
+          <p:nvPr/>
+        </p:nvSpPr>
+        <p:spPr>
+          <a:xfrm>
+            <a:off x="2200655" y="1527048"/>
+            <a:ext cx="1761743" cy="420624"/>
+          </a:xfrm>
+          <a:prstGeom prst="roundRect">
+            <a:avLst>
+              <a:gd name="adj" fmla="val 10869"/>
+            </a:avLst>
+          </a:prstGeom>
+          <a:solidFill>
+            <a:srgbClr val="FFFFFF"/>
+          </a:solidFill>
+          <a:ln w="12700">
+            <a:solidFill>
+              <a:srgbClr val="BFDBFE"/>
+            </a:solidFill>
+          </a:ln>
+          <a:effectLst/>
+        </p:spPr>
+        <p:style>
+          <a:lnRef idx="1">
+            <a:schemeClr val="accent1"/>
+          </a:lnRef>
+          <a:fillRef idx="3">
+            <a:schemeClr val="accent1"/>
+          </a:fillRef>
+          <a:effectRef idx="2">
+            <a:schemeClr val="accent1"/>
+          </a:effectRef>
+          <a:fontRef idx="minor">
+            <a:schemeClr val="lt1"/>
+          </a:fontRef>
+        </p:style>
+        <p:txBody>
+          <a:bodyPr rtlCol="0" anchor="ctr"/>
+          <a:lstStyle/>
+          <a:p>
+            <a:pPr algn="ctr"/>
+          </a:p>
+        </p:txBody>
+      </p:sp>
+      <p:sp>
+        <p:nvSpPr>
+          <p:cNvPr id="14" name="TextBox 13"/>
+          <p:cNvSpPr txBox="1"/>
+          <p:nvPr/>
+        </p:nvSpPr>
+        <p:spPr>
+          <a:xfrm>
+            <a:off x="2200655" y="1527048"/>
+            <a:ext cx="1761743" cy="420624"/>
+          </a:xfrm>
+          <a:prstGeom prst="rect">
+            <a:avLst/>
+          </a:prstGeom>
+          <a:noFill/>
+        </p:spPr>
+        <p:txBody>
+          <a:bodyPr wrap="square" lIns="0" rIns="0" tIns="0" bIns="0" anchor="ctr">
+            <a:noAutofit/>
+          </a:bodyPr>
+          <a:lstStyle/>
+          <a:p>
+            <a:pPr algn="ctr">
+              <a:lnSpc>
+                <a:spcPct val="112000"/>
+              </a:lnSpc>
+              <a:spcBef>
+                <a:spcPts val="0"/>
+              </a:spcBef>
+              <a:spcAft>
+                <a:spcPts val="0"/>
+              </a:spcAft>
+            </a:pPr>
+            <a:r>
+              <a:rPr sz="620" b="0" i="0">
+                <a:solidFill>
+                  <a:srgbClr val="475569"/>
+                </a:solidFill>
+                <a:latin typeface="Segoe UI"/>
+                <a:ea typeface="Microsoft YaHei"/>
+              </a:rPr>
+              <a:t>PostgreSQL</a:t>
+            </a:r>
+          </a:p>
+        </p:txBody>
+      </p:sp>
+      <p:sp>
+        <p:nvSpPr>
+          <p:cNvPr id="15" name="Rounded Rectangle 14"/>
+          <p:cNvSpPr/>
+          <p:nvPr/>
+        </p:nvSpPr>
+        <p:spPr>
+          <a:xfrm>
+            <a:off x="4053839" y="1527048"/>
+            <a:ext cx="1761743" cy="420624"/>
+          </a:xfrm>
+          <a:prstGeom prst="roundRect">
+            <a:avLst>
+              <a:gd name="adj" fmla="val 10869"/>
+            </a:avLst>
+          </a:prstGeom>
+          <a:solidFill>
+            <a:srgbClr val="FFFFFF"/>
+          </a:solidFill>
+          <a:ln w="12700">
+            <a:solidFill>
+              <a:srgbClr val="BFDBFE"/>
+            </a:solidFill>
+          </a:ln>
+          <a:effectLst/>
+        </p:spPr>
+        <p:style>
+          <a:lnRef idx="1">
+            <a:schemeClr val="accent1"/>
+          </a:lnRef>
+          <a:fillRef idx="3">
+            <a:schemeClr val="accent1"/>
+          </a:fillRef>
+          <a:effectRef idx="2">
+            <a:schemeClr val="accent1"/>
+          </a:effectRef>
+          <a:fontRef idx="minor">
+            <a:schemeClr val="lt1"/>
+          </a:fontRef>
+        </p:style>
+        <p:txBody>
+          <a:bodyPr rtlCol="0" anchor="ctr"/>
+          <a:lstStyle/>
+          <a:p>
+            <a:pPr algn="ctr"/>
+          </a:p>
+        </p:txBody>
+      </p:sp>
+      <p:sp>
+        <p:nvSpPr>
+          <p:cNvPr id="16" name="TextBox 15"/>
+          <p:cNvSpPr txBox="1"/>
+          <p:nvPr/>
+        </p:nvSpPr>
+        <p:spPr>
+          <a:xfrm>
+            <a:off x="4053839" y="1527048"/>
+            <a:ext cx="1761743" cy="420624"/>
+          </a:xfrm>
+          <a:prstGeom prst="rect">
+            <a:avLst/>
+          </a:prstGeom>
+          <a:noFill/>
+        </p:spPr>
+        <p:txBody>
+          <a:bodyPr wrap="square" lIns="0" rIns="0" tIns="0" bIns="0" anchor="ctr">
+            <a:noAutofit/>
+          </a:bodyPr>
+          <a:lstStyle/>
+          <a:p>
+            <a:pPr algn="ctr">
+              <a:lnSpc>
+                <a:spcPct val="112000"/>
+              </a:lnSpc>
+              <a:spcBef>
+                <a:spcPts val="0"/>
+              </a:spcBef>
+              <a:spcAft>
+                <a:spcPts val="0"/>
+              </a:spcAft>
+            </a:pPr>
+            <a:r>
+              <a:rPr sz="620" b="0" i="0">
+                <a:solidFill>
+                  <a:srgbClr val="475569"/>
+                </a:solidFill>
+                <a:latin typeface="Segoe UI"/>
+                <a:ea typeface="Microsoft YaHei"/>
+              </a:rPr>
+              <a:t>Oracle</a:t>
+            </a:r>
+          </a:p>
+        </p:txBody>
+      </p:sp>
+      <p:sp>
+        <p:nvSpPr>
+          <p:cNvPr id="17" name="Rounded Rectangle 16"/>
+          <p:cNvSpPr/>
+          <p:nvPr/>
+        </p:nvSpPr>
+        <p:spPr>
+          <a:xfrm>
+            <a:off x="347472" y="2057400"/>
+            <a:ext cx="1761743" cy="420624"/>
+          </a:xfrm>
+          <a:prstGeom prst="roundRect">
+            <a:avLst>
+              <a:gd name="adj" fmla="val 10869"/>
+            </a:avLst>
+          </a:prstGeom>
+          <a:solidFill>
+            <a:srgbClr val="FFFFFF"/>
+          </a:solidFill>
+          <a:ln w="12700">
+            <a:solidFill>
+              <a:srgbClr val="BFDBFE"/>
+            </a:solidFill>
+          </a:ln>
+          <a:effectLst/>
+        </p:spPr>
+        <p:style>
+          <a:lnRef idx="1">
+            <a:schemeClr val="accent1"/>
+          </a:lnRef>
+          <a:fillRef idx="3">
+            <a:schemeClr val="accent1"/>
+          </a:fillRef>
+          <a:effectRef idx="2">
+            <a:schemeClr val="accent1"/>
+          </a:effectRef>
+          <a:fontRef idx="minor">
+            <a:schemeClr val="lt1"/>
+          </a:fontRef>
+        </p:style>
+        <p:txBody>
+          <a:bodyPr rtlCol="0" anchor="ctr"/>
+          <a:lstStyle/>
+          <a:p>
+            <a:pPr algn="ctr"/>
+          </a:p>
+        </p:txBody>
+      </p:sp>
+      <p:sp>
+        <p:nvSpPr>
+          <p:cNvPr id="18" name="TextBox 17"/>
+          <p:cNvSpPr txBox="1"/>
+          <p:nvPr/>
+        </p:nvSpPr>
+        <p:spPr>
+          <a:xfrm>
+            <a:off x="347472" y="2057400"/>
+            <a:ext cx="1761743" cy="420624"/>
+          </a:xfrm>
+          <a:prstGeom prst="rect">
+            <a:avLst/>
+          </a:prstGeom>
+          <a:noFill/>
+        </p:spPr>
+        <p:txBody>
+          <a:bodyPr wrap="square" lIns="0" rIns="0" tIns="0" bIns="0" anchor="ctr">
+            <a:noAutofit/>
+          </a:bodyPr>
+          <a:lstStyle/>
+          <a:p>
+            <a:pPr algn="ctr">
+              <a:lnSpc>
+                <a:spcPct val="112000"/>
+              </a:lnSpc>
+              <a:spcBef>
+                <a:spcPts val="0"/>
+              </a:spcBef>
+              <a:spcAft>
+                <a:spcPts val="0"/>
+              </a:spcAft>
+            </a:pPr>
+            <a:r>
+              <a:rPr sz="620" b="0" i="0">
+                <a:solidFill>
+                  <a:srgbClr val="475569"/>
+                </a:solidFill>
+                <a:latin typeface="Segoe UI"/>
+                <a:ea typeface="Microsoft YaHei"/>
+              </a:rPr>
+              <a:t>SQL Server</a:t>
+            </a:r>
+          </a:p>
+        </p:txBody>
+      </p:sp>
+      <p:sp>
+        <p:nvSpPr>
+          <p:cNvPr id="19" name="Rounded Rectangle 18"/>
+          <p:cNvSpPr/>
+          <p:nvPr/>
+        </p:nvSpPr>
+        <p:spPr>
+          <a:xfrm>
+            <a:off x="2200655" y="2057400"/>
+            <a:ext cx="1761743" cy="420624"/>
+          </a:xfrm>
+          <a:prstGeom prst="roundRect">
+            <a:avLst>
+              <a:gd name="adj" fmla="val 10869"/>
+            </a:avLst>
+          </a:prstGeom>
+          <a:solidFill>
+            <a:srgbClr val="FFFFFF"/>
+          </a:solidFill>
+          <a:ln w="12700">
+            <a:solidFill>
+              <a:srgbClr val="BFDBFE"/>
+            </a:solidFill>
+          </a:ln>
+          <a:effectLst/>
+        </p:spPr>
+        <p:style>
+          <a:lnRef idx="1">
+            <a:schemeClr val="accent1"/>
+          </a:lnRef>
+          <a:fillRef idx="3">
+            <a:schemeClr val="accent1"/>
+          </a:fillRef>
+          <a:effectRef idx="2">
+            <a:schemeClr val="accent1"/>
+          </a:effectRef>
+          <a:fontRef idx="minor">
+            <a:schemeClr val="lt1"/>
+          </a:fontRef>
+        </p:style>
+        <p:txBody>
+          <a:bodyPr rtlCol="0" anchor="ctr"/>
+          <a:lstStyle/>
+          <a:p>
+            <a:pPr algn="ctr"/>
+          </a:p>
+        </p:txBody>
+      </p:sp>
+      <p:sp>
+        <p:nvSpPr>
+          <p:cNvPr id="20" name="TextBox 19"/>
+          <p:cNvSpPr txBox="1"/>
+          <p:nvPr/>
+        </p:nvSpPr>
+        <p:spPr>
+          <a:xfrm>
+            <a:off x="2200655" y="2057400"/>
+            <a:ext cx="1761743" cy="420624"/>
+          </a:xfrm>
+          <a:prstGeom prst="rect">
+            <a:avLst/>
+          </a:prstGeom>
+          <a:noFill/>
+        </p:spPr>
+        <p:txBody>
+          <a:bodyPr wrap="square" lIns="0" rIns="0" tIns="0" bIns="0" anchor="ctr">
+            <a:noAutofit/>
+          </a:bodyPr>
+          <a:lstStyle/>
+          <a:p>
+            <a:pPr algn="ctr">
+              <a:lnSpc>
+                <a:spcPct val="112000"/>
+              </a:lnSpc>
+              <a:spcBef>
+                <a:spcPts val="0"/>
+              </a:spcBef>
+              <a:spcAft>
+                <a:spcPts val="0"/>
+              </a:spcAft>
+            </a:pPr>
+            <a:r>
+              <a:rPr sz="620" b="0" i="0">
+                <a:solidFill>
+                  <a:srgbClr val="475569"/>
+                </a:solidFill>
+                <a:latin typeface="Segoe UI"/>
+                <a:ea typeface="Microsoft YaHei"/>
+              </a:rPr>
+              <a:t>TiDB</a:t>
+            </a:r>
+          </a:p>
+        </p:txBody>
+      </p:sp>
+      <p:sp>
+        <p:nvSpPr>
+          <p:cNvPr id="21" name="Rounded Rectangle 20"/>
+          <p:cNvSpPr/>
+          <p:nvPr/>
+        </p:nvSpPr>
+        <p:spPr>
+          <a:xfrm>
+            <a:off x="4053839" y="2057400"/>
+            <a:ext cx="1761743" cy="420624"/>
+          </a:xfrm>
+          <a:prstGeom prst="roundRect">
+            <a:avLst>
+              <a:gd name="adj" fmla="val 10869"/>
+            </a:avLst>
+          </a:prstGeom>
+          <a:solidFill>
+            <a:srgbClr val="FFFFFF"/>
+          </a:solidFill>
+          <a:ln w="12700">
+            <a:solidFill>
+              <a:srgbClr val="BFDBFE"/>
+            </a:solidFill>
+          </a:ln>
+          <a:effectLst/>
+        </p:spPr>
+        <p:style>
+          <a:lnRef idx="1">
+            <a:schemeClr val="accent1"/>
+          </a:lnRef>
+          <a:fillRef idx="3">
+            <a:schemeClr val="accent1"/>
+          </a:fillRef>
+          <a:effectRef idx="2">
+            <a:schemeClr val="accent1"/>
+          </a:effectRef>
+          <a:fontRef idx="minor">
+            <a:schemeClr val="lt1"/>
+          </a:fontRef>
+        </p:style>
+        <p:txBody>
+          <a:bodyPr rtlCol="0" anchor="ctr"/>
+          <a:lstStyle/>
+          <a:p>
+            <a:pPr algn="ctr"/>
+          </a:p>
+        </p:txBody>
+      </p:sp>
+      <p:sp>
+        <p:nvSpPr>
+          <p:cNvPr id="22" name="TextBox 21"/>
+          <p:cNvSpPr txBox="1"/>
+          <p:nvPr/>
+        </p:nvSpPr>
+        <p:spPr>
+          <a:xfrm>
+            <a:off x="4053839" y="2057400"/>
+            <a:ext cx="1761743" cy="420624"/>
+          </a:xfrm>
+          <a:prstGeom prst="rect">
+            <a:avLst/>
+          </a:prstGeom>
+          <a:noFill/>
+        </p:spPr>
+        <p:txBody>
+          <a:bodyPr wrap="square" lIns="0" rIns="0" tIns="0" bIns="0" anchor="ctr">
+            <a:noAutofit/>
+          </a:bodyPr>
+          <a:lstStyle/>
+          <a:p>
+            <a:pPr algn="ctr">
+              <a:lnSpc>
+                <a:spcPct val="112000"/>
+              </a:lnSpc>
+              <a:spcBef>
+                <a:spcPts val="0"/>
+              </a:spcBef>
+              <a:spcAft>
+                <a:spcPts val="0"/>
+              </a:spcAft>
+            </a:pPr>
+            <a:r>
+              <a:rPr sz="620" b="0" i="0">
+                <a:solidFill>
+                  <a:srgbClr val="475569"/>
+                </a:solidFill>
+                <a:latin typeface="Segoe UI"/>
+                <a:ea typeface="Microsoft YaHei"/>
+              </a:rPr>
+              <a:t>MariaDB</a:t>
+            </a:r>
+          </a:p>
+        </p:txBody>
+      </p:sp>
+      <p:sp>
+        <p:nvSpPr>
+          <p:cNvPr id="23" name="Rounded Rectangle 22"/>
+          <p:cNvSpPr/>
+          <p:nvPr/>
+        </p:nvSpPr>
+        <p:spPr>
+          <a:xfrm>
+            <a:off x="6135624" y="1005840"/>
+            <a:ext cx="5852160" cy="1572768"/>
+          </a:xfrm>
+          <a:prstGeom prst="roundRect">
+            <a:avLst>
+              <a:gd name="adj" fmla="val 4069"/>
+            </a:avLst>
+          </a:prstGeom>
+          <a:solidFill>
+            <a:srgbClr val="FFFBEB"/>
+          </a:solidFill>
+          <a:ln w="15240">
+            <a:solidFill>
+              <a:srgbClr val="FDE68A"/>
+            </a:solidFill>
+          </a:ln>
+          <a:effectLst/>
+        </p:spPr>
+        <p:style>
+          <a:lnRef idx="1">
+            <a:schemeClr val="accent1"/>
+          </a:lnRef>
+          <a:fillRef idx="3">
+            <a:schemeClr val="accent1"/>
+          </a:fillRef>
+          <a:effectRef idx="2">
+            <a:schemeClr val="accent1"/>
+          </a:effectRef>
+          <a:fontRef idx="minor">
+            <a:schemeClr val="lt1"/>
+          </a:fontRef>
+        </p:style>
+        <p:txBody>
+          <a:bodyPr rtlCol="0" anchor="ctr"/>
+          <a:lstStyle/>
+          <a:p>
+            <a:pPr algn="ctr"/>
+          </a:p>
+        </p:txBody>
+      </p:sp>
+      <p:sp>
+        <p:nvSpPr>
+          <p:cNvPr id="24" name="Rounded Rectangle 23"/>
+          <p:cNvSpPr/>
+          <p:nvPr/>
+        </p:nvSpPr>
+        <p:spPr>
+          <a:xfrm>
+            <a:off x="6135624" y="1005840"/>
+            <a:ext cx="36576" cy="1572768"/>
+          </a:xfrm>
+          <a:prstGeom prst="roundRect">
+            <a:avLst>
+              <a:gd name="adj" fmla="val 50000"/>
+            </a:avLst>
+          </a:prstGeom>
+          <a:solidFill>
+            <a:srgbClr val="D97706"/>
+          </a:solidFill>
+          <a:ln>
+            <a:noFill/>
+          </a:ln>
+          <a:effectLst/>
+        </p:spPr>
+        <p:style>
+          <a:lnRef idx="1">
+            <a:schemeClr val="accent1"/>
+          </a:lnRef>
+          <a:fillRef idx="3">
+            <a:schemeClr val="accent1"/>
+          </a:fillRef>
+          <a:effectRef idx="2">
+            <a:schemeClr val="accent1"/>
+          </a:effectRef>
+          <a:fontRef idx="minor">
+            <a:schemeClr val="lt1"/>
+          </a:fontRef>
+        </p:style>
+        <p:txBody>
+          <a:bodyPr rtlCol="0" anchor="ctr"/>
+          <a:lstStyle/>
+          <a:p>
+            <a:pPr algn="ctr"/>
+          </a:p>
+        </p:txBody>
+      </p:sp>
+      <p:sp>
+        <p:nvSpPr>
+          <p:cNvPr id="25" name="TextBox 24"/>
+          <p:cNvSpPr txBox="1"/>
+          <p:nvPr/>
+        </p:nvSpPr>
+        <p:spPr>
+          <a:xfrm>
+            <a:off x="6281928" y="1097280"/>
+            <a:ext cx="5559552" cy="219456"/>
+          </a:xfrm>
+          <a:prstGeom prst="rect">
+            <a:avLst/>
+          </a:prstGeom>
+          <a:noFill/>
+        </p:spPr>
+        <p:txBody>
+          <a:bodyPr wrap="square" lIns="0" rIns="0" tIns="0" bIns="0" anchor="t">
+            <a:noAutofit/>
+          </a:bodyPr>
+          <a:lstStyle/>
+          <a:p>
+            <a:pPr algn="l">
+              <a:lnSpc>
+                <a:spcPct val="112000"/>
+              </a:lnSpc>
+              <a:spcBef>
+                <a:spcPts val="0"/>
+              </a:spcBef>
+              <a:spcAft>
+                <a:spcPts val="0"/>
+              </a:spcAft>
+            </a:pPr>
+            <a:r>
+              <a:rPr sz="940" b="1" i="0">
+                <a:solidFill>
+                  <a:srgbClr val="0F172A"/>
+                </a:solidFill>
+                <a:latin typeface="Segoe UI"/>
+                <a:ea typeface="Microsoft YaHei"/>
+              </a:rPr>
+              <a:t>流式与消息系统</a:t>
+            </a:r>
+          </a:p>
+        </p:txBody>
+      </p:sp>
+      <p:sp>
+        <p:nvSpPr>
+          <p:cNvPr id="26" name="TextBox 25"/>
+          <p:cNvSpPr txBox="1"/>
+          <p:nvPr/>
+        </p:nvSpPr>
+        <p:spPr>
+          <a:xfrm>
+            <a:off x="6281928" y="1325880"/>
+            <a:ext cx="5559552" cy="137160"/>
+          </a:xfrm>
+          <a:prstGeom prst="rect">
+            <a:avLst/>
+          </a:prstGeom>
+          <a:noFill/>
+        </p:spPr>
+        <p:txBody>
+          <a:bodyPr wrap="square" lIns="0" rIns="0" tIns="0" bIns="0" anchor="t">
+            <a:noAutofit/>
+          </a:bodyPr>
+          <a:lstStyle/>
+          <a:p>
+            <a:pPr algn="l">
+              <a:lnSpc>
+                <a:spcPct val="112000"/>
+              </a:lnSpc>
+              <a:spcBef>
+                <a:spcPts val="0"/>
+              </a:spcBef>
+              <a:spcAft>
+                <a:spcPts val="0"/>
+              </a:spcAft>
+            </a:pPr>
+            <a:r>
+              <a:rPr sz="620" b="1" i="0">
+                <a:solidFill>
+                  <a:srgbClr val="D97706"/>
+                </a:solidFill>
+                <a:latin typeface="Segoe UI"/>
+                <a:ea typeface="Microsoft YaHei"/>
+              </a:rPr>
+              <a:t>消息发布 / 订阅</a:t>
+            </a:r>
+          </a:p>
+        </p:txBody>
+      </p:sp>
+      <p:sp>
+        <p:nvSpPr>
+          <p:cNvPr id="27" name="Rounded Rectangle 26"/>
+          <p:cNvSpPr/>
+          <p:nvPr/>
+        </p:nvSpPr>
+        <p:spPr>
+          <a:xfrm>
+            <a:off x="6281928" y="1527048"/>
+            <a:ext cx="1792224" cy="420624"/>
+          </a:xfrm>
+          <a:prstGeom prst="roundRect">
+            <a:avLst>
+              <a:gd name="adj" fmla="val 10869"/>
+            </a:avLst>
+          </a:prstGeom>
+          <a:solidFill>
+            <a:srgbClr val="FFFFFF"/>
+          </a:solidFill>
+          <a:ln w="12700">
+            <a:solidFill>
+              <a:srgbClr val="FDE68A"/>
+            </a:solidFill>
+          </a:ln>
+          <a:effectLst/>
+        </p:spPr>
+        <p:style>
+          <a:lnRef idx="1">
+            <a:schemeClr val="accent1"/>
+          </a:lnRef>
+          <a:fillRef idx="3">
+            <a:schemeClr val="accent1"/>
+          </a:fillRef>
+          <a:effectRef idx="2">
+            <a:schemeClr val="accent1"/>
+          </a:effectRef>
+          <a:fontRef idx="minor">
+            <a:schemeClr val="lt1"/>
+          </a:fontRef>
+        </p:style>
+        <p:txBody>
+          <a:bodyPr rtlCol="0" anchor="ctr"/>
+          <a:lstStyle/>
+          <a:p>
+            <a:pPr algn="ctr"/>
+          </a:p>
+        </p:txBody>
+      </p:sp>
+      <p:sp>
+        <p:nvSpPr>
+          <p:cNvPr id="28" name="TextBox 27"/>
+          <p:cNvSpPr txBox="1"/>
+          <p:nvPr/>
+        </p:nvSpPr>
+        <p:spPr>
+          <a:xfrm>
+            <a:off x="6281928" y="1527048"/>
+            <a:ext cx="1792224" cy="420624"/>
+          </a:xfrm>
+          <a:prstGeom prst="rect">
+            <a:avLst/>
+          </a:prstGeom>
+          <a:noFill/>
+        </p:spPr>
+        <p:txBody>
+          <a:bodyPr wrap="square" lIns="0" rIns="0" tIns="0" bIns="0" anchor="ctr">
+            <a:noAutofit/>
+          </a:bodyPr>
+          <a:lstStyle/>
+          <a:p>
+            <a:pPr algn="ctr">
+              <a:lnSpc>
+                <a:spcPct val="112000"/>
+              </a:lnSpc>
+              <a:spcBef>
+                <a:spcPts val="0"/>
+              </a:spcBef>
+              <a:spcAft>
+                <a:spcPts val="0"/>
+              </a:spcAft>
+            </a:pPr>
+            <a:r>
+              <a:rPr sz="620" b="0" i="0">
+                <a:solidFill>
+                  <a:srgbClr val="475569"/>
+                </a:solidFill>
+                <a:latin typeface="Segoe UI"/>
+                <a:ea typeface="Microsoft YaHei"/>
+              </a:rPr>
+              <a:t>Apache Kafka</a:t>
+            </a:r>
+          </a:p>
+        </p:txBody>
+      </p:sp>
+      <p:sp>
+        <p:nvSpPr>
+          <p:cNvPr id="29" name="Rounded Rectangle 28"/>
+          <p:cNvSpPr/>
+          <p:nvPr/>
+        </p:nvSpPr>
+        <p:spPr>
+          <a:xfrm>
+            <a:off x="8165592" y="1527048"/>
+            <a:ext cx="1792224" cy="420624"/>
+          </a:xfrm>
+          <a:prstGeom prst="roundRect">
+            <a:avLst>
+              <a:gd name="adj" fmla="val 10869"/>
+            </a:avLst>
+          </a:prstGeom>
+          <a:solidFill>
+            <a:srgbClr val="FFFFFF"/>
+          </a:solidFill>
+          <a:ln w="12700">
+            <a:solidFill>
+              <a:srgbClr val="FDE68A"/>
+            </a:solidFill>
+          </a:ln>
+          <a:effectLst/>
+        </p:spPr>
+        <p:style>
+          <a:lnRef idx="1">
+            <a:schemeClr val="accent1"/>
+          </a:lnRef>
+          <a:fillRef idx="3">
+            <a:schemeClr val="accent1"/>
+          </a:fillRef>
+          <a:effectRef idx="2">
+            <a:schemeClr val="accent1"/>
+          </a:effectRef>
+          <a:fontRef idx="minor">
+            <a:schemeClr val="lt1"/>
+          </a:fontRef>
+        </p:style>
+        <p:txBody>
+          <a:bodyPr rtlCol="0" anchor="ctr"/>
+          <a:lstStyle/>
+          <a:p>
+            <a:pPr algn="ctr"/>
+          </a:p>
+        </p:txBody>
+      </p:sp>
+      <p:sp>
+        <p:nvSpPr>
+          <p:cNvPr id="30" name="TextBox 29"/>
+          <p:cNvSpPr txBox="1"/>
+          <p:nvPr/>
+        </p:nvSpPr>
+        <p:spPr>
+          <a:xfrm>
+            <a:off x="8165592" y="1527048"/>
+            <a:ext cx="1792224" cy="420624"/>
+          </a:xfrm>
+          <a:prstGeom prst="rect">
+            <a:avLst/>
+          </a:prstGeom>
+          <a:noFill/>
+        </p:spPr>
+        <p:txBody>
+          <a:bodyPr wrap="square" lIns="0" rIns="0" tIns="0" bIns="0" anchor="ctr">
+            <a:noAutofit/>
+          </a:bodyPr>
+          <a:lstStyle/>
+          <a:p>
+            <a:pPr algn="ctr">
+              <a:lnSpc>
+                <a:spcPct val="112000"/>
+              </a:lnSpc>
+              <a:spcBef>
+                <a:spcPts val="0"/>
+              </a:spcBef>
+              <a:spcAft>
+                <a:spcPts val="0"/>
+              </a:spcAft>
+            </a:pPr>
+            <a:r>
+              <a:rPr sz="620" b="0" i="0">
+                <a:solidFill>
+                  <a:srgbClr val="475569"/>
+                </a:solidFill>
+                <a:latin typeface="Segoe UI"/>
+                <a:ea typeface="Microsoft YaHei"/>
+              </a:rPr>
+              <a:t>Apache Pulsar</a:t>
+            </a:r>
+          </a:p>
+        </p:txBody>
+      </p:sp>
+      <p:sp>
+        <p:nvSpPr>
+          <p:cNvPr id="31" name="Rounded Rectangle 30"/>
+          <p:cNvSpPr/>
+          <p:nvPr/>
+        </p:nvSpPr>
+        <p:spPr>
+          <a:xfrm>
+            <a:off x="10049256" y="1527048"/>
+            <a:ext cx="1792224" cy="420624"/>
+          </a:xfrm>
+          <a:prstGeom prst="roundRect">
+            <a:avLst>
+              <a:gd name="adj" fmla="val 10869"/>
+            </a:avLst>
+          </a:prstGeom>
+          <a:solidFill>
+            <a:srgbClr val="FFFFFF"/>
+          </a:solidFill>
+          <a:ln w="12700">
+            <a:solidFill>
+              <a:srgbClr val="FDE68A"/>
+            </a:solidFill>
+          </a:ln>
+          <a:effectLst/>
+        </p:spPr>
+        <p:style>
+          <a:lnRef idx="1">
+            <a:schemeClr val="accent1"/>
+          </a:lnRef>
+          <a:fillRef idx="3">
+            <a:schemeClr val="accent1"/>
+          </a:fillRef>
+          <a:effectRef idx="2">
+            <a:schemeClr val="accent1"/>
+          </a:effectRef>
+          <a:fontRef idx="minor">
+            <a:schemeClr val="lt1"/>
+          </a:fontRef>
+        </p:style>
+        <p:txBody>
+          <a:bodyPr rtlCol="0" anchor="ctr"/>
+          <a:lstStyle/>
+          <a:p>
+            <a:pPr algn="ctr"/>
+          </a:p>
+        </p:txBody>
+      </p:sp>
+      <p:sp>
+        <p:nvSpPr>
+          <p:cNvPr id="32" name="TextBox 31"/>
+          <p:cNvSpPr txBox="1"/>
+          <p:nvPr/>
+        </p:nvSpPr>
+        <p:spPr>
+          <a:xfrm>
+            <a:off x="10049256" y="1527048"/>
+            <a:ext cx="1792224" cy="420624"/>
+          </a:xfrm>
+          <a:prstGeom prst="rect">
+            <a:avLst/>
+          </a:prstGeom>
+          <a:noFill/>
+        </p:spPr>
+        <p:txBody>
+          <a:bodyPr wrap="square" lIns="0" rIns="0" tIns="0" bIns="0" anchor="ctr">
+            <a:noAutofit/>
+          </a:bodyPr>
+          <a:lstStyle/>
+          <a:p>
+            <a:pPr algn="ctr">
+              <a:lnSpc>
+                <a:spcPct val="112000"/>
+              </a:lnSpc>
+              <a:spcBef>
+                <a:spcPts val="0"/>
+              </a:spcBef>
+              <a:spcAft>
+                <a:spcPts val="0"/>
+              </a:spcAft>
+            </a:pPr>
+            <a:r>
+              <a:rPr sz="620" b="0" i="0">
+                <a:solidFill>
+                  <a:srgbClr val="475569"/>
+                </a:solidFill>
+                <a:latin typeface="Segoe UI"/>
+                <a:ea typeface="Microsoft YaHei"/>
+              </a:rPr>
+              <a:t>RabbitMQ</a:t>
+            </a:r>
+          </a:p>
+        </p:txBody>
+      </p:sp>
+      <p:sp>
+        <p:nvSpPr>
+          <p:cNvPr id="33" name="Rounded Rectangle 32"/>
+          <p:cNvSpPr/>
+          <p:nvPr/>
+        </p:nvSpPr>
+        <p:spPr>
+          <a:xfrm>
+            <a:off x="6281928" y="2057400"/>
+            <a:ext cx="1792224" cy="420624"/>
+          </a:xfrm>
+          <a:prstGeom prst="roundRect">
+            <a:avLst>
+              <a:gd name="adj" fmla="val 10869"/>
+            </a:avLst>
+          </a:prstGeom>
+          <a:solidFill>
+            <a:srgbClr val="FFFFFF"/>
+          </a:solidFill>
+          <a:ln w="12700">
+            <a:solidFill>
+              <a:srgbClr val="FDE68A"/>
+            </a:solidFill>
+          </a:ln>
+          <a:effectLst/>
+        </p:spPr>
+        <p:style>
+          <a:lnRef idx="1">
+            <a:schemeClr val="accent1"/>
+          </a:lnRef>
+          <a:fillRef idx="3">
+            <a:schemeClr val="accent1"/>
+          </a:fillRef>
+          <a:effectRef idx="2">
+            <a:schemeClr val="accent1"/>
+          </a:effectRef>
+          <a:fontRef idx="minor">
+            <a:schemeClr val="lt1"/>
+          </a:fontRef>
+        </p:style>
+        <p:txBody>
+          <a:bodyPr rtlCol="0" anchor="ctr"/>
+          <a:lstStyle/>
+          <a:p>
+            <a:pPr algn="ctr"/>
+          </a:p>
+        </p:txBody>
+      </p:sp>
+      <p:sp>
+        <p:nvSpPr>
+          <p:cNvPr id="34" name="TextBox 33"/>
+          <p:cNvSpPr txBox="1"/>
+          <p:nvPr/>
+        </p:nvSpPr>
+        <p:spPr>
+          <a:xfrm>
+            <a:off x="6281928" y="2057400"/>
+            <a:ext cx="1792224" cy="420624"/>
+          </a:xfrm>
+          <a:prstGeom prst="rect">
+            <a:avLst/>
+          </a:prstGeom>
+          <a:noFill/>
+        </p:spPr>
+        <p:txBody>
+          <a:bodyPr wrap="square" lIns="0" rIns="0" tIns="0" bIns="0" anchor="ctr">
+            <a:noAutofit/>
+          </a:bodyPr>
+          <a:lstStyle/>
+          <a:p>
+            <a:pPr algn="ctr">
+              <a:lnSpc>
+                <a:spcPct val="112000"/>
+              </a:lnSpc>
+              <a:spcBef>
+                <a:spcPts val="0"/>
+              </a:spcBef>
+              <a:spcAft>
+                <a:spcPts val="0"/>
+              </a:spcAft>
+            </a:pPr>
+            <a:r>
+              <a:rPr sz="620" b="0" i="0">
+                <a:solidFill>
+                  <a:srgbClr val="475569"/>
+                </a:solidFill>
+                <a:latin typeface="Segoe UI"/>
+                <a:ea typeface="Microsoft YaHei"/>
+              </a:rPr>
+              <a:t>RocketMQ</a:t>
+            </a:r>
+          </a:p>
+        </p:txBody>
+      </p:sp>
+      <p:sp>
+        <p:nvSpPr>
+          <p:cNvPr id="35" name="Rounded Rectangle 34"/>
+          <p:cNvSpPr/>
+          <p:nvPr/>
+        </p:nvSpPr>
+        <p:spPr>
+          <a:xfrm>
+            <a:off x="8165592" y="2057400"/>
+            <a:ext cx="1792224" cy="420624"/>
+          </a:xfrm>
+          <a:prstGeom prst="roundRect">
+            <a:avLst>
+              <a:gd name="adj" fmla="val 10869"/>
+            </a:avLst>
+          </a:prstGeom>
+          <a:solidFill>
+            <a:srgbClr val="FFFFFF"/>
+          </a:solidFill>
+          <a:ln w="12700">
+            <a:solidFill>
+              <a:srgbClr val="FDE68A"/>
+            </a:solidFill>
+          </a:ln>
+          <a:effectLst/>
+        </p:spPr>
+        <p:style>
+          <a:lnRef idx="1">
+            <a:schemeClr val="accent1"/>
+          </a:lnRef>
+          <a:fillRef idx="3">
+            <a:schemeClr val="accent1"/>
+          </a:fillRef>
+          <a:effectRef idx="2">
+            <a:schemeClr val="accent1"/>
+          </a:effectRef>
+          <a:fontRef idx="minor">
+            <a:schemeClr val="lt1"/>
+          </a:fontRef>
+        </p:style>
+        <p:txBody>
+          <a:bodyPr rtlCol="0" anchor="ctr"/>
+          <a:lstStyle/>
+          <a:p>
+            <a:pPr algn="ctr"/>
+          </a:p>
+        </p:txBody>
+      </p:sp>
+      <p:sp>
+        <p:nvSpPr>
+          <p:cNvPr id="36" name="TextBox 35"/>
+          <p:cNvSpPr txBox="1"/>
+          <p:nvPr/>
+        </p:nvSpPr>
+        <p:spPr>
+          <a:xfrm>
+            <a:off x="8165592" y="2057400"/>
+            <a:ext cx="1792224" cy="420624"/>
+          </a:xfrm>
+          <a:prstGeom prst="rect">
+            <a:avLst/>
+          </a:prstGeom>
+          <a:noFill/>
+        </p:spPr>
+        <p:txBody>
+          <a:bodyPr wrap="square" lIns="0" rIns="0" tIns="0" bIns="0" anchor="ctr">
+            <a:noAutofit/>
+          </a:bodyPr>
+          <a:lstStyle/>
+          <a:p>
+            <a:pPr algn="ctr">
+              <a:lnSpc>
+                <a:spcPct val="112000"/>
+              </a:lnSpc>
+              <a:spcBef>
+                <a:spcPts val="0"/>
+              </a:spcBef>
+              <a:spcAft>
+                <a:spcPts val="0"/>
+              </a:spcAft>
+            </a:pPr>
+            <a:r>
+              <a:rPr sz="620" b="0" i="0">
+                <a:solidFill>
+                  <a:srgbClr val="475569"/>
+                </a:solidFill>
+                <a:latin typeface="Segoe UI"/>
+                <a:ea typeface="Microsoft YaHei"/>
+              </a:rPr>
+              <a:t>AWS SQS</a:t>
+            </a:r>
+          </a:p>
+        </p:txBody>
+      </p:sp>
+      <p:sp>
+        <p:nvSpPr>
+          <p:cNvPr id="37" name="Rounded Rectangle 36"/>
+          <p:cNvSpPr/>
+          <p:nvPr/>
+        </p:nvSpPr>
+        <p:spPr>
+          <a:xfrm>
+            <a:off x="10049256" y="2057400"/>
+            <a:ext cx="1792224" cy="420624"/>
+          </a:xfrm>
+          <a:prstGeom prst="roundRect">
+            <a:avLst>
+              <a:gd name="adj" fmla="val 10869"/>
+            </a:avLst>
+          </a:prstGeom>
+          <a:solidFill>
+            <a:srgbClr val="FFFFFF"/>
+          </a:solidFill>
+          <a:ln w="12700">
+            <a:solidFill>
+              <a:srgbClr val="FDE68A"/>
+            </a:solidFill>
+          </a:ln>
+          <a:effectLst/>
+        </p:spPr>
+        <p:style>
+          <a:lnRef idx="1">
+            <a:schemeClr val="accent1"/>
+          </a:lnRef>
+          <a:fillRef idx="3">
+            <a:schemeClr val="accent1"/>
+          </a:fillRef>
+          <a:effectRef idx="2">
+            <a:schemeClr val="accent1"/>
+          </a:effectRef>
+          <a:fontRef idx="minor">
+            <a:schemeClr val="lt1"/>
+          </a:fontRef>
+        </p:style>
+        <p:txBody>
+          <a:bodyPr rtlCol="0" anchor="ctr"/>
+          <a:lstStyle/>
+          <a:p>
+            <a:pPr algn="ctr"/>
+          </a:p>
+        </p:txBody>
+      </p:sp>
+      <p:sp>
+        <p:nvSpPr>
+          <p:cNvPr id="38" name="TextBox 37"/>
+          <p:cNvSpPr txBox="1"/>
+          <p:nvPr/>
+        </p:nvSpPr>
+        <p:spPr>
+          <a:xfrm>
+            <a:off x="10049256" y="2057400"/>
+            <a:ext cx="1792224" cy="420624"/>
+          </a:xfrm>
+          <a:prstGeom prst="rect">
+            <a:avLst/>
+          </a:prstGeom>
+          <a:noFill/>
+        </p:spPr>
+        <p:txBody>
+          <a:bodyPr wrap="square" lIns="0" rIns="0" tIns="0" bIns="0" anchor="ctr">
+            <a:noAutofit/>
+          </a:bodyPr>
+          <a:lstStyle/>
+          <a:p>
+            <a:pPr algn="ctr">
+              <a:lnSpc>
+                <a:spcPct val="112000"/>
+              </a:lnSpc>
+              <a:spcBef>
+                <a:spcPts val="0"/>
+              </a:spcBef>
+              <a:spcAft>
+                <a:spcPts val="0"/>
+              </a:spcAft>
+            </a:pPr>
+            <a:r>
+              <a:rPr sz="620" b="0" i="0">
+                <a:solidFill>
+                  <a:srgbClr val="475569"/>
+                </a:solidFill>
+                <a:latin typeface="Segoe UI"/>
+                <a:ea typeface="Microsoft YaHei"/>
+              </a:rPr>
+              <a:t>ActiveMQ</a:t>
+            </a:r>
+          </a:p>
+        </p:txBody>
+      </p:sp>
+      <p:sp>
+        <p:nvSpPr>
+          <p:cNvPr id="39" name="Rounded Rectangle 38"/>
+          <p:cNvSpPr/>
+          <p:nvPr/>
+        </p:nvSpPr>
+        <p:spPr>
+          <a:xfrm>
+            <a:off x="201168" y="2706624"/>
+            <a:ext cx="5760720" cy="1572768"/>
+          </a:xfrm>
+          <a:prstGeom prst="roundRect">
+            <a:avLst>
+              <a:gd name="adj" fmla="val 4069"/>
+            </a:avLst>
+          </a:prstGeom>
+          <a:solidFill>
+            <a:srgbClr val="F5F3FF"/>
+          </a:solidFill>
+          <a:ln w="15240">
+            <a:solidFill>
+              <a:srgbClr val="DDD6FE"/>
+            </a:solidFill>
+          </a:ln>
+          <a:effectLst/>
+        </p:spPr>
+        <p:style>
+          <a:lnRef idx="1">
+            <a:schemeClr val="accent1"/>
+          </a:lnRef>
+          <a:fillRef idx="3">
+            <a:schemeClr val="accent1"/>
+          </a:fillRef>
+          <a:effectRef idx="2">
+            <a:schemeClr val="accent1"/>
+          </a:effectRef>
+          <a:fontRef idx="minor">
+            <a:schemeClr val="lt1"/>
+          </a:fontRef>
+        </p:style>
+        <p:txBody>
+          <a:bodyPr rtlCol="0" anchor="ctr"/>
+          <a:lstStyle/>
+          <a:p>
+            <a:pPr algn="ctr"/>
+          </a:p>
+        </p:txBody>
+      </p:sp>
+      <p:sp>
+        <p:nvSpPr>
+          <p:cNvPr id="40" name="Rounded Rectangle 39"/>
+          <p:cNvSpPr/>
+          <p:nvPr/>
+        </p:nvSpPr>
+        <p:spPr>
+          <a:xfrm>
+            <a:off x="201168" y="2706624"/>
+            <a:ext cx="36576" cy="1572768"/>
+          </a:xfrm>
+          <a:prstGeom prst="roundRect">
+            <a:avLst>
+              <a:gd name="adj" fmla="val 50000"/>
+            </a:avLst>
+          </a:prstGeom>
+          <a:solidFill>
+            <a:srgbClr val="7C3AED"/>
+          </a:solidFill>
+          <a:ln>
+            <a:noFill/>
+          </a:ln>
+          <a:effectLst/>
+        </p:spPr>
+        <p:style>
+          <a:lnRef idx="1">
+            <a:schemeClr val="accent1"/>
+          </a:lnRef>
+          <a:fillRef idx="3">
+            <a:schemeClr val="accent1"/>
+          </a:fillRef>
+          <a:effectRef idx="2">
+            <a:schemeClr val="accent1"/>
+          </a:effectRef>
+          <a:fontRef idx="minor">
+            <a:schemeClr val="lt1"/>
+          </a:fontRef>
+        </p:style>
+        <p:txBody>
+          <a:bodyPr rtlCol="0" anchor="ctr"/>
+          <a:lstStyle/>
+          <a:p>
+            <a:pPr algn="ctr"/>
+          </a:p>
+        </p:txBody>
+      </p:sp>
+      <p:sp>
+        <p:nvSpPr>
+          <p:cNvPr id="41" name="TextBox 40"/>
+          <p:cNvSpPr txBox="1"/>
+          <p:nvPr/>
+        </p:nvSpPr>
+        <p:spPr>
+          <a:xfrm>
+            <a:off x="347472" y="2798064"/>
+            <a:ext cx="5468112" cy="219456"/>
+          </a:xfrm>
+          <a:prstGeom prst="rect">
+            <a:avLst/>
+          </a:prstGeom>
+          <a:noFill/>
+        </p:spPr>
+        <p:txBody>
+          <a:bodyPr wrap="square" lIns="0" rIns="0" tIns="0" bIns="0" anchor="t">
+            <a:noAutofit/>
+          </a:bodyPr>
+          <a:lstStyle/>
+          <a:p>
+            <a:pPr algn="l">
+              <a:lnSpc>
+                <a:spcPct val="112000"/>
+              </a:lnSpc>
+              <a:spcBef>
+                <a:spcPts val="0"/>
+              </a:spcBef>
+              <a:spcAft>
+                <a:spcPts val="0"/>
+              </a:spcAft>
+            </a:pPr>
+            <a:r>
+              <a:rPr sz="940" b="1" i="0">
+                <a:solidFill>
+                  <a:srgbClr val="0F172A"/>
+                </a:solidFill>
+                <a:latin typeface="Segoe UI"/>
+                <a:ea typeface="Microsoft YaHei"/>
+              </a:rPr>
+              <a:t>OLAP 与分析</a:t>
+            </a:r>
+          </a:p>
+        </p:txBody>
+      </p:sp>
+      <p:sp>
+        <p:nvSpPr>
+          <p:cNvPr id="42" name="TextBox 41"/>
+          <p:cNvSpPr txBox="1"/>
+          <p:nvPr/>
+        </p:nvSpPr>
+        <p:spPr>
+          <a:xfrm>
+            <a:off x="347472" y="3026664"/>
+            <a:ext cx="5468112" cy="137160"/>
+          </a:xfrm>
+          <a:prstGeom prst="rect">
+            <a:avLst/>
+          </a:prstGeom>
+          <a:noFill/>
+        </p:spPr>
+        <p:txBody>
+          <a:bodyPr wrap="square" lIns="0" rIns="0" tIns="0" bIns="0" anchor="t">
+            <a:noAutofit/>
+          </a:bodyPr>
+          <a:lstStyle/>
+          <a:p>
+            <a:pPr algn="l">
+              <a:lnSpc>
+                <a:spcPct val="112000"/>
+              </a:lnSpc>
+              <a:spcBef>
+                <a:spcPts val="0"/>
+              </a:spcBef>
+              <a:spcAft>
+                <a:spcPts val="0"/>
+              </a:spcAft>
+            </a:pPr>
+            <a:r>
+              <a:rPr sz="620" b="1" i="0">
+                <a:solidFill>
+                  <a:srgbClr val="7C3AED"/>
+                </a:solidFill>
+                <a:latin typeface="Segoe UI"/>
+                <a:ea typeface="Microsoft YaHei"/>
+              </a:rPr>
+              <a:t>分析型 OLAP 引擎</a:t>
+            </a:r>
+          </a:p>
+        </p:txBody>
+      </p:sp>
+      <p:sp>
+        <p:nvSpPr>
+          <p:cNvPr id="43" name="Rounded Rectangle 42"/>
+          <p:cNvSpPr/>
+          <p:nvPr/>
+        </p:nvSpPr>
+        <p:spPr>
+          <a:xfrm>
+            <a:off x="347472" y="3227832"/>
+            <a:ext cx="1761743" cy="420624"/>
+          </a:xfrm>
+          <a:prstGeom prst="roundRect">
+            <a:avLst>
+              <a:gd name="adj" fmla="val 10869"/>
+            </a:avLst>
+          </a:prstGeom>
+          <a:solidFill>
+            <a:srgbClr val="FFFFFF"/>
+          </a:solidFill>
+          <a:ln w="12700">
+            <a:solidFill>
+              <a:srgbClr val="DDD6FE"/>
+            </a:solidFill>
+          </a:ln>
+          <a:effectLst/>
+        </p:spPr>
+        <p:style>
+          <a:lnRef idx="1">
+            <a:schemeClr val="accent1"/>
+          </a:lnRef>
+          <a:fillRef idx="3">
+            <a:schemeClr val="accent1"/>
+          </a:fillRef>
+          <a:effectRef idx="2">
+            <a:schemeClr val="accent1"/>
+          </a:effectRef>
+          <a:fontRef idx="minor">
+            <a:schemeClr val="lt1"/>
+          </a:fontRef>
+        </p:style>
+        <p:txBody>
+          <a:bodyPr rtlCol="0" anchor="ctr"/>
+          <a:lstStyle/>
+          <a:p>
+            <a:pPr algn="ctr"/>
+          </a:p>
+        </p:txBody>
+      </p:sp>
+      <p:sp>
+        <p:nvSpPr>
+          <p:cNvPr id="44" name="TextBox 43"/>
+          <p:cNvSpPr txBox="1"/>
+          <p:nvPr/>
+        </p:nvSpPr>
+        <p:spPr>
+          <a:xfrm>
+            <a:off x="347472" y="3227832"/>
+            <a:ext cx="1761743" cy="420624"/>
+          </a:xfrm>
+          <a:prstGeom prst="rect">
+            <a:avLst/>
+          </a:prstGeom>
+          <a:noFill/>
+        </p:spPr>
+        <p:txBody>
+          <a:bodyPr wrap="square" lIns="0" rIns="0" tIns="0" bIns="0" anchor="ctr">
+            <a:noAutofit/>
+          </a:bodyPr>
+          <a:lstStyle/>
+          <a:p>
+            <a:pPr algn="ctr">
+              <a:lnSpc>
+                <a:spcPct val="112000"/>
+              </a:lnSpc>
+              <a:spcBef>
+                <a:spcPts val="0"/>
+              </a:spcBef>
+              <a:spcAft>
+                <a:spcPts val="0"/>
+              </a:spcAft>
+            </a:pPr>
+            <a:r>
+              <a:rPr sz="620" b="0" i="0">
+                <a:solidFill>
+                  <a:srgbClr val="475569"/>
+                </a:solidFill>
+                <a:latin typeface="Segoe UI"/>
+                <a:ea typeface="Microsoft YaHei"/>
+              </a:rPr>
+              <a:t>ClickHouse</a:t>
+            </a:r>
+          </a:p>
+        </p:txBody>
+      </p:sp>
+      <p:sp>
+        <p:nvSpPr>
+          <p:cNvPr id="45" name="Rounded Rectangle 44"/>
+          <p:cNvSpPr/>
+          <p:nvPr/>
+        </p:nvSpPr>
+        <p:spPr>
+          <a:xfrm>
+            <a:off x="2200655" y="3227832"/>
+            <a:ext cx="1761743" cy="420624"/>
+          </a:xfrm>
+          <a:prstGeom prst="roundRect">
+            <a:avLst>
+              <a:gd name="adj" fmla="val 10869"/>
+            </a:avLst>
+          </a:prstGeom>
+          <a:solidFill>
+            <a:srgbClr val="FFFFFF"/>
+          </a:solidFill>
+          <a:ln w="12700">
+            <a:solidFill>
+              <a:srgbClr val="DDD6FE"/>
+            </a:solidFill>
+          </a:ln>
+          <a:effectLst/>
+        </p:spPr>
+        <p:style>
+          <a:lnRef idx="1">
+            <a:schemeClr val="accent1"/>
+          </a:lnRef>
+          <a:fillRef idx="3">
+            <a:schemeClr val="accent1"/>
+          </a:fillRef>
+          <a:effectRef idx="2">
+            <a:schemeClr val="accent1"/>
+          </a:effectRef>
+          <a:fontRef idx="minor">
+            <a:schemeClr val="lt1"/>
+          </a:fontRef>
+        </p:style>
+        <p:txBody>
+          <a:bodyPr rtlCol="0" anchor="ctr"/>
+          <a:lstStyle/>
+          <a:p>
+            <a:pPr algn="ctr"/>
+          </a:p>
+        </p:txBody>
+      </p:sp>
+      <p:sp>
+        <p:nvSpPr>
+          <p:cNvPr id="46" name="TextBox 45"/>
+          <p:cNvSpPr txBox="1"/>
+          <p:nvPr/>
+        </p:nvSpPr>
+        <p:spPr>
+          <a:xfrm>
+            <a:off x="2200655" y="3227832"/>
+            <a:ext cx="1761743" cy="420624"/>
+          </a:xfrm>
+          <a:prstGeom prst="rect">
+            <a:avLst/>
+          </a:prstGeom>
+          <a:noFill/>
+        </p:spPr>
+        <p:txBody>
+          <a:bodyPr wrap="square" lIns="0" rIns="0" tIns="0" bIns="0" anchor="ctr">
+            <a:noAutofit/>
+          </a:bodyPr>
+          <a:lstStyle/>
+          <a:p>
+            <a:pPr algn="ctr">
+              <a:lnSpc>
+                <a:spcPct val="112000"/>
+              </a:lnSpc>
+              <a:spcBef>
+                <a:spcPts val="0"/>
+              </a:spcBef>
+              <a:spcAft>
+                <a:spcPts val="0"/>
+              </a:spcAft>
+            </a:pPr>
+            <a:r>
+              <a:rPr sz="620" b="0" i="0">
+                <a:solidFill>
+                  <a:srgbClr val="475569"/>
+                </a:solidFill>
+                <a:latin typeface="Segoe UI"/>
+                <a:ea typeface="Microsoft YaHei"/>
+              </a:rPr>
+              <a:t>Apache Doris</a:t>
+            </a:r>
+          </a:p>
+        </p:txBody>
+      </p:sp>
+      <p:sp>
+        <p:nvSpPr>
+          <p:cNvPr id="47" name="Rounded Rectangle 46"/>
+          <p:cNvSpPr/>
+          <p:nvPr/>
+        </p:nvSpPr>
+        <p:spPr>
+          <a:xfrm>
+            <a:off x="4053839" y="3227832"/>
+            <a:ext cx="1761743" cy="420624"/>
+          </a:xfrm>
+          <a:prstGeom prst="roundRect">
+            <a:avLst>
+              <a:gd name="adj" fmla="val 10869"/>
+            </a:avLst>
+          </a:prstGeom>
+          <a:solidFill>
+            <a:srgbClr val="FFFFFF"/>
+          </a:solidFill>
+          <a:ln w="12700">
+            <a:solidFill>
+              <a:srgbClr val="DDD6FE"/>
+            </a:solidFill>
+          </a:ln>
+          <a:effectLst/>
+        </p:spPr>
+        <p:style>
+          <a:lnRef idx="1">
+            <a:schemeClr val="accent1"/>
+          </a:lnRef>
+          <a:fillRef idx="3">
+            <a:schemeClr val="accent1"/>
+          </a:fillRef>
+          <a:effectRef idx="2">
+            <a:schemeClr val="accent1"/>
+          </a:effectRef>
+          <a:fontRef idx="minor">
+            <a:schemeClr val="lt1"/>
+          </a:fontRef>
+        </p:style>
+        <p:txBody>
+          <a:bodyPr rtlCol="0" anchor="ctr"/>
+          <a:lstStyle/>
+          <a:p>
+            <a:pPr algn="ctr"/>
+          </a:p>
+        </p:txBody>
+      </p:sp>
+      <p:sp>
+        <p:nvSpPr>
+          <p:cNvPr id="48" name="TextBox 47"/>
+          <p:cNvSpPr txBox="1"/>
+          <p:nvPr/>
+        </p:nvSpPr>
+        <p:spPr>
+          <a:xfrm>
+            <a:off x="4053839" y="3227832"/>
+            <a:ext cx="1761743" cy="420624"/>
+          </a:xfrm>
+          <a:prstGeom prst="rect">
+            <a:avLst/>
+          </a:prstGeom>
+          <a:noFill/>
+        </p:spPr>
+        <p:txBody>
+          <a:bodyPr wrap="square" lIns="0" rIns="0" tIns="0" bIns="0" anchor="ctr">
+            <a:noAutofit/>
+          </a:bodyPr>
+          <a:lstStyle/>
+          <a:p>
+            <a:pPr algn="ctr">
+              <a:lnSpc>
+                <a:spcPct val="112000"/>
+              </a:lnSpc>
+              <a:spcBef>
+                <a:spcPts val="0"/>
+              </a:spcBef>
+              <a:spcAft>
+                <a:spcPts val="0"/>
+              </a:spcAft>
+            </a:pPr>
+            <a:r>
+              <a:rPr sz="620" b="0" i="0">
+                <a:solidFill>
+                  <a:srgbClr val="475569"/>
+                </a:solidFill>
+                <a:latin typeface="Segoe UI"/>
+                <a:ea typeface="Microsoft YaHei"/>
+              </a:rPr>
+              <a:t>StarRocks</a:t>
+            </a:r>
+          </a:p>
+        </p:txBody>
+      </p:sp>
+      <p:sp>
+        <p:nvSpPr>
+          <p:cNvPr id="49" name="Rounded Rectangle 48"/>
+          <p:cNvSpPr/>
+          <p:nvPr/>
+        </p:nvSpPr>
+        <p:spPr>
+          <a:xfrm>
+            <a:off x="347472" y="3758183"/>
+            <a:ext cx="1761743" cy="420624"/>
+          </a:xfrm>
+          <a:prstGeom prst="roundRect">
+            <a:avLst>
+              <a:gd name="adj" fmla="val 10869"/>
+            </a:avLst>
+          </a:prstGeom>
+          <a:solidFill>
+            <a:srgbClr val="FFFFFF"/>
+          </a:solidFill>
+          <a:ln w="12700">
+            <a:solidFill>
+              <a:srgbClr val="DDD6FE"/>
+            </a:solidFill>
+          </a:ln>
+          <a:effectLst/>
+        </p:spPr>
+        <p:style>
+          <a:lnRef idx="1">
+            <a:schemeClr val="accent1"/>
+          </a:lnRef>
+          <a:fillRef idx="3">
+            <a:schemeClr val="accent1"/>
+          </a:fillRef>
+          <a:effectRef idx="2">
+            <a:schemeClr val="accent1"/>
+          </a:effectRef>
+          <a:fontRef idx="minor">
+            <a:schemeClr val="lt1"/>
+          </a:fontRef>
+        </p:style>
+        <p:txBody>
+          <a:bodyPr rtlCol="0" anchor="ctr"/>
+          <a:lstStyle/>
+          <a:p>
+            <a:pPr algn="ctr"/>
+          </a:p>
+        </p:txBody>
+      </p:sp>
+      <p:sp>
+        <p:nvSpPr>
+          <p:cNvPr id="50" name="TextBox 49"/>
+          <p:cNvSpPr txBox="1"/>
+          <p:nvPr/>
+        </p:nvSpPr>
+        <p:spPr>
+          <a:xfrm>
+            <a:off x="347472" y="3758183"/>
+            <a:ext cx="1761743" cy="420624"/>
+          </a:xfrm>
+          <a:prstGeom prst="rect">
+            <a:avLst/>
+          </a:prstGeom>
+          <a:noFill/>
+        </p:spPr>
+        <p:txBody>
+          <a:bodyPr wrap="square" lIns="0" rIns="0" tIns="0" bIns="0" anchor="ctr">
+            <a:noAutofit/>
+          </a:bodyPr>
+          <a:lstStyle/>
+          <a:p>
+            <a:pPr algn="ctr">
+              <a:lnSpc>
+                <a:spcPct val="112000"/>
+              </a:lnSpc>
+              <a:spcBef>
+                <a:spcPts val="0"/>
+              </a:spcBef>
+              <a:spcAft>
+                <a:spcPts val="0"/>
+              </a:spcAft>
+            </a:pPr>
+            <a:r>
+              <a:rPr sz="620" b="0" i="0">
+                <a:solidFill>
+                  <a:srgbClr val="475569"/>
+                </a:solidFill>
+                <a:latin typeface="Segoe UI"/>
+                <a:ea typeface="Microsoft YaHei"/>
+              </a:rPr>
+              <a:t>Snowflake</a:t>
+            </a:r>
+          </a:p>
+        </p:txBody>
+      </p:sp>
+      <p:sp>
+        <p:nvSpPr>
+          <p:cNvPr id="51" name="Rounded Rectangle 50"/>
+          <p:cNvSpPr/>
+          <p:nvPr/>
+        </p:nvSpPr>
+        <p:spPr>
+          <a:xfrm>
+            <a:off x="2200655" y="3758183"/>
+            <a:ext cx="1761743" cy="420624"/>
+          </a:xfrm>
+          <a:prstGeom prst="roundRect">
+            <a:avLst>
+              <a:gd name="adj" fmla="val 10869"/>
+            </a:avLst>
+          </a:prstGeom>
+          <a:solidFill>
+            <a:srgbClr val="FFFFFF"/>
+          </a:solidFill>
+          <a:ln w="12700">
+            <a:solidFill>
+              <a:srgbClr val="DDD6FE"/>
+            </a:solidFill>
+          </a:ln>
+          <a:effectLst/>
+        </p:spPr>
+        <p:style>
+          <a:lnRef idx="1">
+            <a:schemeClr val="accent1"/>
+          </a:lnRef>
+          <a:fillRef idx="3">
+            <a:schemeClr val="accent1"/>
+          </a:fillRef>
+          <a:effectRef idx="2">
+            <a:schemeClr val="accent1"/>
+          </a:effectRef>
+          <a:fontRef idx="minor">
+            <a:schemeClr val="lt1"/>
+          </a:fontRef>
+        </p:style>
+        <p:txBody>
+          <a:bodyPr rtlCol="0" anchor="ctr"/>
+          <a:lstStyle/>
+          <a:p>
+            <a:pPr algn="ctr"/>
+          </a:p>
+        </p:txBody>
+      </p:sp>
+      <p:sp>
+        <p:nvSpPr>
+          <p:cNvPr id="52" name="TextBox 51"/>
+          <p:cNvSpPr txBox="1"/>
+          <p:nvPr/>
+        </p:nvSpPr>
+        <p:spPr>
+          <a:xfrm>
+            <a:off x="2200655" y="3758183"/>
+            <a:ext cx="1761743" cy="420624"/>
+          </a:xfrm>
+          <a:prstGeom prst="rect">
+            <a:avLst/>
+          </a:prstGeom>
+          <a:noFill/>
+        </p:spPr>
+        <p:txBody>
+          <a:bodyPr wrap="square" lIns="0" rIns="0" tIns="0" bIns="0" anchor="ctr">
+            <a:noAutofit/>
+          </a:bodyPr>
+          <a:lstStyle/>
+          <a:p>
+            <a:pPr algn="ctr">
+              <a:lnSpc>
+                <a:spcPct val="112000"/>
+              </a:lnSpc>
+              <a:spcBef>
+                <a:spcPts val="0"/>
+              </a:spcBef>
+              <a:spcAft>
+                <a:spcPts val="0"/>
+              </a:spcAft>
+            </a:pPr>
+            <a:r>
+              <a:rPr sz="620" b="0" i="0">
+                <a:solidFill>
+                  <a:srgbClr val="475569"/>
+                </a:solidFill>
+                <a:latin typeface="Segoe UI"/>
+                <a:ea typeface="Microsoft YaHei"/>
+              </a:rPr>
+              <a:t>Amazon Redshift</a:t>
+            </a:r>
+          </a:p>
+        </p:txBody>
+      </p:sp>
+      <p:sp>
+        <p:nvSpPr>
+          <p:cNvPr id="53" name="Rounded Rectangle 52"/>
+          <p:cNvSpPr/>
+          <p:nvPr/>
+        </p:nvSpPr>
+        <p:spPr>
+          <a:xfrm>
+            <a:off x="4053839" y="3758183"/>
+            <a:ext cx="1761743" cy="420624"/>
+          </a:xfrm>
+          <a:prstGeom prst="roundRect">
+            <a:avLst>
+              <a:gd name="adj" fmla="val 10869"/>
+            </a:avLst>
+          </a:prstGeom>
+          <a:solidFill>
+            <a:srgbClr val="FFFFFF"/>
+          </a:solidFill>
+          <a:ln w="12700">
+            <a:solidFill>
+              <a:srgbClr val="DDD6FE"/>
+            </a:solidFill>
+          </a:ln>
+          <a:effectLst/>
+        </p:spPr>
+        <p:style>
+          <a:lnRef idx="1">
+            <a:schemeClr val="accent1"/>
+          </a:lnRef>
+          <a:fillRef idx="3">
+            <a:schemeClr val="accent1"/>
+          </a:fillRef>
+          <a:effectRef idx="2">
+            <a:schemeClr val="accent1"/>
+          </a:effectRef>
+          <a:fontRef idx="minor">
+            <a:schemeClr val="lt1"/>
+          </a:fontRef>
+        </p:style>
+        <p:txBody>
+          <a:bodyPr rtlCol="0" anchor="ctr"/>
+          <a:lstStyle/>
+          <a:p>
+            <a:pPr algn="ctr"/>
+          </a:p>
+        </p:txBody>
+      </p:sp>
+      <p:sp>
+        <p:nvSpPr>
+          <p:cNvPr id="54" name="TextBox 53"/>
+          <p:cNvSpPr txBox="1"/>
+          <p:nvPr/>
+        </p:nvSpPr>
+        <p:spPr>
+          <a:xfrm>
+            <a:off x="4053839" y="3758183"/>
+            <a:ext cx="1761743" cy="420624"/>
+          </a:xfrm>
+          <a:prstGeom prst="rect">
+            <a:avLst/>
+          </a:prstGeom>
+          <a:noFill/>
+        </p:spPr>
+        <p:txBody>
+          <a:bodyPr wrap="square" lIns="0" rIns="0" tIns="0" bIns="0" anchor="ctr">
+            <a:noAutofit/>
+          </a:bodyPr>
+          <a:lstStyle/>
+          <a:p>
+            <a:pPr algn="ctr">
+              <a:lnSpc>
+                <a:spcPct val="112000"/>
+              </a:lnSpc>
+              <a:spcBef>
+                <a:spcPts val="0"/>
+              </a:spcBef>
+              <a:spcAft>
+                <a:spcPts val="0"/>
+              </a:spcAft>
+            </a:pPr>
+            <a:r>
+              <a:rPr sz="620" b="0" i="0">
+                <a:solidFill>
+                  <a:srgbClr val="475569"/>
+                </a:solidFill>
+                <a:latin typeface="Segoe UI"/>
+                <a:ea typeface="Microsoft YaHei"/>
+              </a:rPr>
+              <a:t>Cloudberry</a:t>
+            </a:r>
+          </a:p>
+        </p:txBody>
+      </p:sp>
+      <p:sp>
+        <p:nvSpPr>
+          <p:cNvPr id="55" name="Rounded Rectangle 54"/>
+          <p:cNvSpPr/>
+          <p:nvPr/>
+        </p:nvSpPr>
+        <p:spPr>
+          <a:xfrm>
+            <a:off x="6135624" y="2706624"/>
+            <a:ext cx="5852160" cy="1572768"/>
+          </a:xfrm>
+          <a:prstGeom prst="roundRect">
+            <a:avLst>
+              <a:gd name="adj" fmla="val 4069"/>
+            </a:avLst>
+          </a:prstGeom>
+          <a:solidFill>
+            <a:srgbClr val="ECFDF5"/>
+          </a:solidFill>
+          <a:ln w="15240">
+            <a:solidFill>
+              <a:srgbClr val="A7F3D0"/>
+            </a:solidFill>
+          </a:ln>
+          <a:effectLst/>
+        </p:spPr>
+        <p:style>
+          <a:lnRef idx="1">
+            <a:schemeClr val="accent1"/>
+          </a:lnRef>
+          <a:fillRef idx="3">
+            <a:schemeClr val="accent1"/>
+          </a:fillRef>
+          <a:effectRef idx="2">
+            <a:schemeClr val="accent1"/>
+          </a:effectRef>
+          <a:fontRef idx="minor">
+            <a:schemeClr val="lt1"/>
+          </a:fontRef>
+        </p:style>
+        <p:txBody>
+          <a:bodyPr rtlCol="0" anchor="ctr"/>
+          <a:lstStyle/>
+          <a:p>
+            <a:pPr algn="ctr"/>
+          </a:p>
+        </p:txBody>
+      </p:sp>
+      <p:sp>
+        <p:nvSpPr>
+          <p:cNvPr id="56" name="Rounded Rectangle 55"/>
+          <p:cNvSpPr/>
+          <p:nvPr/>
+        </p:nvSpPr>
+        <p:spPr>
+          <a:xfrm>
+            <a:off x="6135624" y="2706624"/>
+            <a:ext cx="36576" cy="1572768"/>
+          </a:xfrm>
+          <a:prstGeom prst="roundRect">
+            <a:avLst>
+              <a:gd name="adj" fmla="val 50000"/>
+            </a:avLst>
+          </a:prstGeom>
+          <a:solidFill>
+            <a:srgbClr val="059669"/>
+          </a:solidFill>
+          <a:ln>
+            <a:noFill/>
+          </a:ln>
+          <a:effectLst/>
+        </p:spPr>
+        <p:style>
+          <a:lnRef idx="1">
+            <a:schemeClr val="accent1"/>
+          </a:lnRef>
+          <a:fillRef idx="3">
+            <a:schemeClr val="accent1"/>
+          </a:fillRef>
+          <a:effectRef idx="2">
+            <a:schemeClr val="accent1"/>
+          </a:effectRef>
+          <a:fontRef idx="minor">
+            <a:schemeClr val="lt1"/>
+          </a:fontRef>
+        </p:style>
+        <p:txBody>
+          <a:bodyPr rtlCol="0" anchor="ctr"/>
+          <a:lstStyle/>
+          <a:p>
+            <a:pPr algn="ctr"/>
+          </a:p>
+        </p:txBody>
+      </p:sp>
+      <p:sp>
+        <p:nvSpPr>
+          <p:cNvPr id="57" name="TextBox 56"/>
+          <p:cNvSpPr txBox="1"/>
+          <p:nvPr/>
+        </p:nvSpPr>
+        <p:spPr>
+          <a:xfrm>
+            <a:off x="6281928" y="2798064"/>
+            <a:ext cx="5559552" cy="219456"/>
+          </a:xfrm>
+          <a:prstGeom prst="rect">
+            <a:avLst/>
+          </a:prstGeom>
+          <a:noFill/>
+        </p:spPr>
+        <p:txBody>
+          <a:bodyPr wrap="square" lIns="0" rIns="0" tIns="0" bIns="0" anchor="t">
+            <a:noAutofit/>
+          </a:bodyPr>
+          <a:lstStyle/>
+          <a:p>
+            <a:pPr algn="l">
+              <a:lnSpc>
+                <a:spcPct val="112000"/>
+              </a:lnSpc>
+              <a:spcBef>
+                <a:spcPts val="0"/>
+              </a:spcBef>
+              <a:spcAft>
+                <a:spcPts val="0"/>
+              </a:spcAft>
+            </a:pPr>
+            <a:r>
+              <a:rPr sz="940" b="1" i="0">
+                <a:solidFill>
+                  <a:srgbClr val="0F172A"/>
+                </a:solidFill>
+                <a:latin typeface="Segoe UI"/>
+                <a:ea typeface="Microsoft YaHei"/>
+              </a:rPr>
+              <a:t>数据湖与存储</a:t>
+            </a:r>
+          </a:p>
+        </p:txBody>
+      </p:sp>
+      <p:sp>
+        <p:nvSpPr>
+          <p:cNvPr id="58" name="TextBox 57"/>
+          <p:cNvSpPr txBox="1"/>
+          <p:nvPr/>
+        </p:nvSpPr>
+        <p:spPr>
+          <a:xfrm>
+            <a:off x="6281928" y="3026664"/>
+            <a:ext cx="5559552" cy="137160"/>
+          </a:xfrm>
+          <a:prstGeom prst="rect">
+            <a:avLst/>
+          </a:prstGeom>
+          <a:noFill/>
+        </p:spPr>
+        <p:txBody>
+          <a:bodyPr wrap="square" lIns="0" rIns="0" tIns="0" bIns="0" anchor="t">
+            <a:noAutofit/>
+          </a:bodyPr>
+          <a:lstStyle/>
+          <a:p>
+            <a:pPr algn="l">
+              <a:lnSpc>
+                <a:spcPct val="112000"/>
+              </a:lnSpc>
+              <a:spcBef>
+                <a:spcPts val="0"/>
+              </a:spcBef>
+              <a:spcAft>
+                <a:spcPts val="0"/>
+              </a:spcAft>
+            </a:pPr>
+            <a:r>
+              <a:rPr sz="620" b="1" i="0">
+                <a:solidFill>
+                  <a:srgbClr val="059669"/>
+                </a:solidFill>
+                <a:latin typeface="Segoe UI"/>
+                <a:ea typeface="Microsoft YaHei"/>
+              </a:rPr>
+              <a:t>Open Table · 对象存储</a:t>
+            </a:r>
+          </a:p>
+        </p:txBody>
+      </p:sp>
+      <p:sp>
+        <p:nvSpPr>
+          <p:cNvPr id="59" name="Rounded Rectangle 58"/>
+          <p:cNvSpPr/>
+          <p:nvPr/>
+        </p:nvSpPr>
+        <p:spPr>
+          <a:xfrm>
+            <a:off x="6281928" y="3227832"/>
+            <a:ext cx="1792224" cy="420624"/>
+          </a:xfrm>
+          <a:prstGeom prst="roundRect">
+            <a:avLst>
+              <a:gd name="adj" fmla="val 10869"/>
+            </a:avLst>
+          </a:prstGeom>
+          <a:solidFill>
+            <a:srgbClr val="FFFFFF"/>
+          </a:solidFill>
+          <a:ln w="12700">
+            <a:solidFill>
+              <a:srgbClr val="A7F3D0"/>
+            </a:solidFill>
+          </a:ln>
+          <a:effectLst/>
+        </p:spPr>
+        <p:style>
+          <a:lnRef idx="1">
+            <a:schemeClr val="accent1"/>
+          </a:lnRef>
+          <a:fillRef idx="3">
+            <a:schemeClr val="accent1"/>
+          </a:fillRef>
+          <a:effectRef idx="2">
+            <a:schemeClr val="accent1"/>
+          </a:effectRef>
+          <a:fontRef idx="minor">
+            <a:schemeClr val="lt1"/>
+          </a:fontRef>
+        </p:style>
+        <p:txBody>
+          <a:bodyPr rtlCol="0" anchor="ctr"/>
+          <a:lstStyle/>
+          <a:p>
+            <a:pPr algn="ctr"/>
+          </a:p>
+        </p:txBody>
+      </p:sp>
+      <p:sp>
+        <p:nvSpPr>
+          <p:cNvPr id="60" name="TextBox 59"/>
+          <p:cNvSpPr txBox="1"/>
+          <p:nvPr/>
+        </p:nvSpPr>
+        <p:spPr>
+          <a:xfrm>
+            <a:off x="6281928" y="3227832"/>
+            <a:ext cx="1792224" cy="420624"/>
+          </a:xfrm>
+          <a:prstGeom prst="rect">
+            <a:avLst/>
+          </a:prstGeom>
+          <a:noFill/>
+        </p:spPr>
+        <p:txBody>
+          <a:bodyPr wrap="square" lIns="0" rIns="0" tIns="0" bIns="0" anchor="ctr">
+            <a:noAutofit/>
+          </a:bodyPr>
+          <a:lstStyle/>
+          <a:p>
+            <a:pPr algn="ctr">
+              <a:lnSpc>
+                <a:spcPct val="112000"/>
+              </a:lnSpc>
+              <a:spcBef>
+                <a:spcPts val="0"/>
+              </a:spcBef>
+              <a:spcAft>
+                <a:spcPts val="0"/>
+              </a:spcAft>
+            </a:pPr>
+            <a:r>
+              <a:rPr sz="620" b="0" i="0">
+                <a:solidFill>
+                  <a:srgbClr val="475569"/>
+                </a:solidFill>
+                <a:latin typeface="Segoe UI"/>
+                <a:ea typeface="Microsoft YaHei"/>
+              </a:rPr>
+              <a:t>Amazon S3</a:t>
+            </a:r>
+          </a:p>
+        </p:txBody>
+      </p:sp>
+      <p:sp>
+        <p:nvSpPr>
+          <p:cNvPr id="61" name="Rounded Rectangle 60"/>
+          <p:cNvSpPr/>
+          <p:nvPr/>
+        </p:nvSpPr>
+        <p:spPr>
+          <a:xfrm>
+            <a:off x="8165592" y="3227832"/>
+            <a:ext cx="1792224" cy="420624"/>
+          </a:xfrm>
+          <a:prstGeom prst="roundRect">
+            <a:avLst>
+              <a:gd name="adj" fmla="val 10869"/>
+            </a:avLst>
+          </a:prstGeom>
+          <a:solidFill>
+            <a:srgbClr val="FFFFFF"/>
+          </a:solidFill>
+          <a:ln w="12700">
+            <a:solidFill>
+              <a:srgbClr val="A7F3D0"/>
+            </a:solidFill>
+          </a:ln>
+          <a:effectLst/>
+        </p:spPr>
+        <p:style>
+          <a:lnRef idx="1">
+            <a:schemeClr val="accent1"/>
+          </a:lnRef>
+          <a:fillRef idx="3">
+            <a:schemeClr val="accent1"/>
+          </a:fillRef>
+          <a:effectRef idx="2">
+            <a:schemeClr val="accent1"/>
+          </a:effectRef>
+          <a:fontRef idx="minor">
+            <a:schemeClr val="lt1"/>
+          </a:fontRef>
+        </p:style>
+        <p:txBody>
+          <a:bodyPr rtlCol="0" anchor="ctr"/>
+          <a:lstStyle/>
+          <a:p>
+            <a:pPr algn="ctr"/>
+          </a:p>
+        </p:txBody>
+      </p:sp>
+      <p:sp>
+        <p:nvSpPr>
+          <p:cNvPr id="62" name="TextBox 61"/>
+          <p:cNvSpPr txBox="1"/>
+          <p:nvPr/>
+        </p:nvSpPr>
+        <p:spPr>
+          <a:xfrm>
+            <a:off x="8165592" y="3227832"/>
+            <a:ext cx="1792224" cy="420624"/>
+          </a:xfrm>
+          <a:prstGeom prst="rect">
+            <a:avLst/>
+          </a:prstGeom>
+          <a:noFill/>
+        </p:spPr>
+        <p:txBody>
+          <a:bodyPr wrap="square" lIns="0" rIns="0" tIns="0" bIns="0" anchor="ctr">
+            <a:noAutofit/>
+          </a:bodyPr>
+          <a:lstStyle/>
+          <a:p>
+            <a:pPr algn="ctr">
+              <a:lnSpc>
+                <a:spcPct val="112000"/>
+              </a:lnSpc>
+              <a:spcBef>
+                <a:spcPts val="0"/>
+              </a:spcBef>
+              <a:spcAft>
+                <a:spcPts val="0"/>
+              </a:spcAft>
+            </a:pPr>
+            <a:r>
+              <a:rPr sz="620" b="0" i="0">
+                <a:solidFill>
+                  <a:srgbClr val="475569"/>
+                </a:solidFill>
+                <a:latin typeface="Segoe UI"/>
+                <a:ea typeface="Microsoft YaHei"/>
+              </a:rPr>
+              <a:t>Alibaba OSS</a:t>
+            </a:r>
+          </a:p>
+        </p:txBody>
+      </p:sp>
+      <p:sp>
+        <p:nvSpPr>
+          <p:cNvPr id="63" name="Rounded Rectangle 62"/>
+          <p:cNvSpPr/>
+          <p:nvPr/>
+        </p:nvSpPr>
+        <p:spPr>
+          <a:xfrm>
+            <a:off x="10049256" y="3227832"/>
+            <a:ext cx="1792224" cy="420624"/>
+          </a:xfrm>
+          <a:prstGeom prst="roundRect">
+            <a:avLst>
+              <a:gd name="adj" fmla="val 10869"/>
+            </a:avLst>
+          </a:prstGeom>
+          <a:solidFill>
+            <a:srgbClr val="FFFFFF"/>
+          </a:solidFill>
+          <a:ln w="12700">
+            <a:solidFill>
+              <a:srgbClr val="A7F3D0"/>
+            </a:solidFill>
+          </a:ln>
+          <a:effectLst/>
+        </p:spPr>
+        <p:style>
+          <a:lnRef idx="1">
+            <a:schemeClr val="accent1"/>
+          </a:lnRef>
+          <a:fillRef idx="3">
+            <a:schemeClr val="accent1"/>
+          </a:fillRef>
+          <a:effectRef idx="2">
+            <a:schemeClr val="accent1"/>
+          </a:effectRef>
+          <a:fontRef idx="minor">
+            <a:schemeClr val="lt1"/>
+          </a:fontRef>
+        </p:style>
+        <p:txBody>
+          <a:bodyPr rtlCol="0" anchor="ctr"/>
+          <a:lstStyle/>
+          <a:p>
+            <a:pPr algn="ctr"/>
+          </a:p>
+        </p:txBody>
+      </p:sp>
+      <p:sp>
+        <p:nvSpPr>
+          <p:cNvPr id="64" name="TextBox 63"/>
+          <p:cNvSpPr txBox="1"/>
+          <p:nvPr/>
+        </p:nvSpPr>
+        <p:spPr>
+          <a:xfrm>
+            <a:off x="10049256" y="3227832"/>
+            <a:ext cx="1792224" cy="420624"/>
+          </a:xfrm>
+          <a:prstGeom prst="rect">
+            <a:avLst/>
+          </a:prstGeom>
+          <a:noFill/>
+        </p:spPr>
+        <p:txBody>
+          <a:bodyPr wrap="square" lIns="0" rIns="0" tIns="0" bIns="0" anchor="ctr">
+            <a:noAutofit/>
+          </a:bodyPr>
+          <a:lstStyle/>
+          <a:p>
+            <a:pPr algn="ctr">
+              <a:lnSpc>
+                <a:spcPct val="112000"/>
+              </a:lnSpc>
+              <a:spcBef>
+                <a:spcPts val="0"/>
+              </a:spcBef>
+              <a:spcAft>
+                <a:spcPts val="0"/>
+              </a:spcAft>
+            </a:pPr>
+            <a:r>
+              <a:rPr sz="620" b="0" i="0">
+                <a:solidFill>
+                  <a:srgbClr val="475569"/>
+                </a:solidFill>
+                <a:latin typeface="Segoe UI"/>
+                <a:ea typeface="Microsoft YaHei"/>
+              </a:rPr>
+              <a:t>HDFS / LocalFile</a:t>
+            </a:r>
+          </a:p>
+        </p:txBody>
+      </p:sp>
+      <p:sp>
+        <p:nvSpPr>
+          <p:cNvPr id="65" name="Rounded Rectangle 64"/>
+          <p:cNvSpPr/>
+          <p:nvPr/>
+        </p:nvSpPr>
+        <p:spPr>
+          <a:xfrm>
+            <a:off x="6281928" y="3758183"/>
+            <a:ext cx="1792224" cy="420624"/>
+          </a:xfrm>
+          <a:prstGeom prst="roundRect">
+            <a:avLst>
+              <a:gd name="adj" fmla="val 10869"/>
+            </a:avLst>
+          </a:prstGeom>
+          <a:solidFill>
+            <a:srgbClr val="ECFDF5"/>
+          </a:solidFill>
+          <a:ln w="15240">
+            <a:solidFill>
+              <a:srgbClr val="6EE7B7"/>
+            </a:solidFill>
+          </a:ln>
+          <a:effectLst/>
+        </p:spPr>
+        <p:style>
+          <a:lnRef idx="1">
+            <a:schemeClr val="accent1"/>
+          </a:lnRef>
+          <a:fillRef idx="3">
+            <a:schemeClr val="accent1"/>
+          </a:fillRef>
+          <a:effectRef idx="2">
+            <a:schemeClr val="accent1"/>
+          </a:effectRef>
+          <a:fontRef idx="minor">
+            <a:schemeClr val="lt1"/>
+          </a:fontRef>
+        </p:style>
+        <p:txBody>
+          <a:bodyPr rtlCol="0" anchor="ctr"/>
+          <a:lstStyle/>
+          <a:p>
+            <a:pPr algn="ctr"/>
+          </a:p>
+        </p:txBody>
+      </p:sp>
+      <p:sp>
+        <p:nvSpPr>
+          <p:cNvPr id="66" name="TextBox 65"/>
+          <p:cNvSpPr txBox="1"/>
+          <p:nvPr/>
+        </p:nvSpPr>
+        <p:spPr>
+          <a:xfrm>
+            <a:off x="6281928" y="3758183"/>
+            <a:ext cx="1792224" cy="420624"/>
+          </a:xfrm>
+          <a:prstGeom prst="rect">
+            <a:avLst/>
+          </a:prstGeom>
+          <a:noFill/>
+        </p:spPr>
+        <p:txBody>
+          <a:bodyPr wrap="square" lIns="0" rIns="0" tIns="0" bIns="0" anchor="ctr">
+            <a:noAutofit/>
+          </a:bodyPr>
+          <a:lstStyle/>
+          <a:p>
+            <a:pPr algn="ctr">
+              <a:lnSpc>
+                <a:spcPct val="112000"/>
+              </a:lnSpc>
+              <a:spcBef>
+                <a:spcPts val="0"/>
+              </a:spcBef>
+              <a:spcAft>
+                <a:spcPts val="0"/>
+              </a:spcAft>
+            </a:pPr>
+            <a:r>
+              <a:rPr sz="620" b="1" i="0">
+                <a:solidFill>
+                  <a:srgbClr val="047857"/>
+                </a:solidFill>
+                <a:latin typeface="Segoe UI"/>
+                <a:ea typeface="Microsoft YaHei"/>
+              </a:rPr>
+              <a:t>Apache Iceberg</a:t>
+            </a:r>
+          </a:p>
+        </p:txBody>
+      </p:sp>
+      <p:sp>
+        <p:nvSpPr>
+          <p:cNvPr id="67" name="Rounded Rectangle 66"/>
+          <p:cNvSpPr/>
+          <p:nvPr/>
+        </p:nvSpPr>
+        <p:spPr>
+          <a:xfrm>
+            <a:off x="8165592" y="3758183"/>
+            <a:ext cx="1792224" cy="420624"/>
+          </a:xfrm>
+          <a:prstGeom prst="roundRect">
+            <a:avLst>
+              <a:gd name="adj" fmla="val 10869"/>
+            </a:avLst>
+          </a:prstGeom>
+          <a:solidFill>
+            <a:srgbClr val="FFFFFF"/>
+          </a:solidFill>
+          <a:ln w="12700">
+            <a:solidFill>
+              <a:srgbClr val="A7F3D0"/>
+            </a:solidFill>
+          </a:ln>
+          <a:effectLst/>
+        </p:spPr>
+        <p:style>
+          <a:lnRef idx="1">
+            <a:schemeClr val="accent1"/>
+          </a:lnRef>
+          <a:fillRef idx="3">
+            <a:schemeClr val="accent1"/>
+          </a:fillRef>
+          <a:effectRef idx="2">
+            <a:schemeClr val="accent1"/>
+          </a:effectRef>
+          <a:fontRef idx="minor">
+            <a:schemeClr val="lt1"/>
+          </a:fontRef>
+        </p:style>
+        <p:txBody>
+          <a:bodyPr rtlCol="0" anchor="ctr"/>
+          <a:lstStyle/>
+          <a:p>
+            <a:pPr algn="ctr"/>
+          </a:p>
+        </p:txBody>
+      </p:sp>
+      <p:sp>
+        <p:nvSpPr>
+          <p:cNvPr id="68" name="TextBox 67"/>
+          <p:cNvSpPr txBox="1"/>
+          <p:nvPr/>
+        </p:nvSpPr>
+        <p:spPr>
+          <a:xfrm>
+            <a:off x="8165592" y="3758183"/>
+            <a:ext cx="1792224" cy="420624"/>
+          </a:xfrm>
+          <a:prstGeom prst="rect">
+            <a:avLst/>
+          </a:prstGeom>
+          <a:noFill/>
+        </p:spPr>
+        <p:txBody>
+          <a:bodyPr wrap="square" lIns="0" rIns="0" tIns="0" bIns="0" anchor="ctr">
+            <a:noAutofit/>
+          </a:bodyPr>
+          <a:lstStyle/>
+          <a:p>
+            <a:pPr algn="ctr">
+              <a:lnSpc>
+                <a:spcPct val="112000"/>
+              </a:lnSpc>
+              <a:spcBef>
+                <a:spcPts val="0"/>
+              </a:spcBef>
+              <a:spcAft>
+                <a:spcPts val="0"/>
+              </a:spcAft>
+            </a:pPr>
+            <a:r>
+              <a:rPr sz="620" b="0" i="0">
+                <a:solidFill>
+                  <a:srgbClr val="475569"/>
+                </a:solidFill>
+                <a:latin typeface="Segoe UI"/>
+                <a:ea typeface="Microsoft YaHei"/>
+              </a:rPr>
+              <a:t>Delta Lake</a:t>
+            </a:r>
+          </a:p>
+        </p:txBody>
+      </p:sp>
+      <p:sp>
+        <p:nvSpPr>
+          <p:cNvPr id="69" name="Rounded Rectangle 68"/>
+          <p:cNvSpPr/>
+          <p:nvPr/>
+        </p:nvSpPr>
+        <p:spPr>
+          <a:xfrm>
+            <a:off x="10049256" y="3758183"/>
+            <a:ext cx="1792224" cy="420624"/>
+          </a:xfrm>
+          <a:prstGeom prst="roundRect">
+            <a:avLst>
+              <a:gd name="adj" fmla="val 10869"/>
+            </a:avLst>
+          </a:prstGeom>
+          <a:solidFill>
+            <a:srgbClr val="FFFFFF"/>
+          </a:solidFill>
+          <a:ln w="12700">
+            <a:solidFill>
+              <a:srgbClr val="A7F3D0"/>
+            </a:solidFill>
+          </a:ln>
+          <a:effectLst/>
+        </p:spPr>
+        <p:style>
+          <a:lnRef idx="1">
+            <a:schemeClr val="accent1"/>
+          </a:lnRef>
+          <a:fillRef idx="3">
+            <a:schemeClr val="accent1"/>
+          </a:fillRef>
+          <a:effectRef idx="2">
+            <a:schemeClr val="accent1"/>
+          </a:effectRef>
+          <a:fontRef idx="minor">
+            <a:schemeClr val="lt1"/>
+          </a:fontRef>
+        </p:style>
+        <p:txBody>
+          <a:bodyPr rtlCol="0" anchor="ctr"/>
+          <a:lstStyle/>
+          <a:p>
+            <a:pPr algn="ctr"/>
+          </a:p>
+        </p:txBody>
+      </p:sp>
+      <p:sp>
+        <p:nvSpPr>
+          <p:cNvPr id="70" name="TextBox 69"/>
+          <p:cNvSpPr txBox="1"/>
+          <p:nvPr/>
+        </p:nvSpPr>
+        <p:spPr>
+          <a:xfrm>
+            <a:off x="10049256" y="3758183"/>
+            <a:ext cx="1792224" cy="420624"/>
+          </a:xfrm>
+          <a:prstGeom prst="rect">
+            <a:avLst/>
+          </a:prstGeom>
+          <a:noFill/>
+        </p:spPr>
+        <p:txBody>
+          <a:bodyPr wrap="square" lIns="0" rIns="0" tIns="0" bIns="0" anchor="ctr">
+            <a:noAutofit/>
+          </a:bodyPr>
+          <a:lstStyle/>
+          <a:p>
+            <a:pPr algn="ctr">
+              <a:lnSpc>
+                <a:spcPct val="112000"/>
+              </a:lnSpc>
+              <a:spcBef>
+                <a:spcPts val="0"/>
+              </a:spcBef>
+              <a:spcAft>
+                <a:spcPts val="0"/>
+              </a:spcAft>
+            </a:pPr>
+            <a:r>
+              <a:rPr sz="620" b="0" i="0">
+                <a:solidFill>
+                  <a:srgbClr val="475569"/>
+                </a:solidFill>
+                <a:latin typeface="Segoe UI"/>
+                <a:ea typeface="Microsoft YaHei"/>
+              </a:rPr>
+              <a:t>Apache Paimon</a:t>
+            </a:r>
+          </a:p>
+        </p:txBody>
+      </p:sp>
+      <p:sp>
+        <p:nvSpPr>
+          <p:cNvPr id="71" name="Rounded Rectangle 70"/>
+          <p:cNvSpPr/>
+          <p:nvPr/>
+        </p:nvSpPr>
+        <p:spPr>
+          <a:xfrm>
+            <a:off x="201168" y="4425696"/>
+            <a:ext cx="11786616" cy="1847088"/>
+          </a:xfrm>
+          <a:prstGeom prst="roundRect">
+            <a:avLst>
+              <a:gd name="adj" fmla="val 3465"/>
+            </a:avLst>
+          </a:prstGeom>
+          <a:solidFill>
+            <a:srgbClr val="FFFFFF"/>
+          </a:solidFill>
+          <a:ln w="15240">
+            <a:solidFill>
+              <a:srgbClr val="E2E8F0"/>
+            </a:solidFill>
+          </a:ln>
+          <a:effectLst/>
+        </p:spPr>
+        <p:style>
+          <a:lnRef idx="1">
+            <a:schemeClr val="accent1"/>
+          </a:lnRef>
+          <a:fillRef idx="3">
+            <a:schemeClr val="accent1"/>
+          </a:fillRef>
+          <a:effectRef idx="2">
+            <a:schemeClr val="accent1"/>
+          </a:effectRef>
+          <a:fontRef idx="minor">
+            <a:schemeClr val="lt1"/>
+          </a:fontRef>
+        </p:style>
+        <p:txBody>
+          <a:bodyPr rtlCol="0" anchor="ctr"/>
+          <a:lstStyle/>
+          <a:p>
+            <a:pPr algn="ctr"/>
+          </a:p>
+        </p:txBody>
+      </p:sp>
+      <p:sp>
+        <p:nvSpPr>
+          <p:cNvPr id="72" name="TextBox 71"/>
+          <p:cNvSpPr txBox="1"/>
+          <p:nvPr/>
+        </p:nvSpPr>
+        <p:spPr>
+          <a:xfrm>
+            <a:off x="347472" y="4517136"/>
+            <a:ext cx="11430000" cy="201168"/>
+          </a:xfrm>
+          <a:prstGeom prst="rect">
+            <a:avLst/>
+          </a:prstGeom>
+          <a:noFill/>
+        </p:spPr>
+        <p:txBody>
+          <a:bodyPr wrap="square" lIns="0" rIns="0" tIns="0" bIns="0" anchor="t">
+            <a:noAutofit/>
+          </a:bodyPr>
+          <a:lstStyle/>
+          <a:p>
+            <a:pPr algn="l">
+              <a:lnSpc>
+                <a:spcPct val="112000"/>
+              </a:lnSpc>
+              <a:spcBef>
+                <a:spcPts val="0"/>
+              </a:spcBef>
+              <a:spcAft>
+                <a:spcPts val="0"/>
+              </a:spcAft>
+            </a:pPr>
+            <a:r>
+              <a:rPr sz="850" b="1" i="0">
+                <a:solidFill>
+                  <a:srgbClr val="0F172A"/>
+                </a:solidFill>
+                <a:latin typeface="Segoe UI"/>
+                <a:ea typeface="Microsoft YaHei"/>
+              </a:rPr>
+              <a:t>其余连接器 · 全量约 200 个（节选）</a:t>
+            </a:r>
+          </a:p>
+        </p:txBody>
+      </p:sp>
+      <p:sp>
+        <p:nvSpPr>
+          <p:cNvPr id="73" name="TextBox 72"/>
+          <p:cNvSpPr txBox="1"/>
+          <p:nvPr/>
+        </p:nvSpPr>
+        <p:spPr>
+          <a:xfrm>
+            <a:off x="347472" y="4791456"/>
+            <a:ext cx="11430000" cy="384048"/>
+          </a:xfrm>
+          <a:prstGeom prst="rect">
+            <a:avLst/>
+          </a:prstGeom>
+          <a:noFill/>
+        </p:spPr>
+        <p:txBody>
+          <a:bodyPr wrap="square" lIns="0" rIns="0" tIns="0" bIns="0" anchor="t">
+            <a:noAutofit/>
+          </a:bodyPr>
+          <a:lstStyle/>
+          <a:p>
+            <a:pPr algn="l">
+              <a:lnSpc>
+                <a:spcPct val="125000"/>
+              </a:lnSpc>
+              <a:spcBef>
+                <a:spcPts val="0"/>
+              </a:spcBef>
+              <a:spcAft>
+                <a:spcPts val="0"/>
+              </a:spcAft>
+            </a:pPr>
+            <a:r>
+              <a:rPr sz="630" b="0" i="0">
+                <a:solidFill>
+                  <a:srgbClr val="64748B"/>
+                </a:solidFill>
+                <a:latin typeface="Segoe UI"/>
+                <a:ea typeface="Microsoft YaHei"/>
+              </a:rPr>
+              <a:t>数据库：MySQL · PostgreSQL · Oracle · SQL Server · TiDB · MariaDB · MongoDB · DynamoDB · Cassandra · HBase · Neo4j · DB2 · Greenplum · OceanBase · Redis · Aerospike</a:t>
+            </a:r>
+          </a:p>
+        </p:txBody>
+      </p:sp>
+      <p:sp>
+        <p:nvSpPr>
+          <p:cNvPr id="74" name="TextBox 73"/>
+          <p:cNvSpPr txBox="1"/>
+          <p:nvPr/>
+        </p:nvSpPr>
+        <p:spPr>
+          <a:xfrm>
+            <a:off x="347472" y="5212080"/>
+            <a:ext cx="11430000" cy="384048"/>
+          </a:xfrm>
+          <a:prstGeom prst="rect">
+            <a:avLst/>
+          </a:prstGeom>
+          <a:noFill/>
+        </p:spPr>
+        <p:txBody>
+          <a:bodyPr wrap="square" lIns="0" rIns="0" tIns="0" bIns="0" anchor="t">
+            <a:noAutofit/>
+          </a:bodyPr>
+          <a:lstStyle/>
+          <a:p>
+            <a:pPr algn="l">
+              <a:lnSpc>
+                <a:spcPct val="125000"/>
+              </a:lnSpc>
+              <a:spcBef>
+                <a:spcPts val="0"/>
+              </a:spcBef>
+              <a:spcAft>
+                <a:spcPts val="0"/>
+              </a:spcAft>
+            </a:pPr>
+            <a:r>
+              <a:rPr sz="630" b="0" i="0">
+                <a:solidFill>
+                  <a:srgbClr val="64748B"/>
+                </a:solidFill>
+                <a:latin typeface="Segoe UI"/>
+                <a:ea typeface="Microsoft YaHei"/>
+              </a:rPr>
+              <a:t>消息 / 检索 / 向量：Kafka · Pulsar · RabbitMQ · RocketMQ · ActiveMQ · SQS · Elasticsearch · Druid · Typesense · Milvus · Qdrant · Lance · HugeGraph · InfluxDB · IoTDB · TDengine</a:t>
+            </a:r>
+          </a:p>
+        </p:txBody>
+      </p:sp>
+      <p:sp>
+        <p:nvSpPr>
+          <p:cNvPr id="75" name="TextBox 74"/>
+          <p:cNvSpPr txBox="1"/>
+          <p:nvPr/>
+        </p:nvSpPr>
+        <p:spPr>
+          <a:xfrm>
+            <a:off x="347472" y="5632704"/>
+            <a:ext cx="11430000" cy="384048"/>
+          </a:xfrm>
+          <a:prstGeom prst="rect">
+            <a:avLst/>
+          </a:prstGeom>
+          <a:noFill/>
+        </p:spPr>
+        <p:txBody>
+          <a:bodyPr wrap="square" lIns="0" rIns="0" tIns="0" bIns="0" anchor="t">
+            <a:noAutofit/>
+          </a:bodyPr>
+          <a:lstStyle/>
+          <a:p>
+            <a:pPr algn="l">
+              <a:lnSpc>
+                <a:spcPct val="125000"/>
+              </a:lnSpc>
+              <a:spcBef>
+                <a:spcPts val="0"/>
+              </a:spcBef>
+              <a:spcAft>
+                <a:spcPts val="0"/>
+              </a:spcAft>
+            </a:pPr>
+            <a:r>
+              <a:rPr sz="630" b="0" i="0">
+                <a:solidFill>
+                  <a:srgbClr val="64748B"/>
+                </a:solidFill>
+                <a:latin typeface="Segoe UI"/>
+                <a:ea typeface="Microsoft YaHei"/>
+              </a:rPr>
+              <a:t>文件 / 协作 / 其他：FTP · SFTP · HTTP · GraphQL · Google Sheets · Firestore · Slack · DingTalk · Feishu · Email · MaxCompute · Prometheus · SLS · Sentry · Web3j …</a:t>
+            </a:r>
+          </a:p>
+        </p:txBody>
+      </p:sp>
+      <p:sp>
+        <p:nvSpPr>
+          <p:cNvPr id="76" name="TextBox 75"/>
+          <p:cNvSpPr txBox="1"/>
+          <p:nvPr/>
+        </p:nvSpPr>
+        <p:spPr>
+          <a:xfrm>
+            <a:off x="347472" y="6089904"/>
+            <a:ext cx="11430000" cy="128016"/>
+          </a:xfrm>
+          <a:prstGeom prst="rect">
+            <a:avLst/>
+          </a:prstGeom>
+          <a:noFill/>
+        </p:spPr>
+        <p:txBody>
+          <a:bodyPr wrap="square" lIns="0" rIns="0" tIns="0" bIns="0" anchor="t">
+            <a:noAutofit/>
+          </a:bodyPr>
+          <a:lstStyle/>
+          <a:p>
+            <a:pPr algn="l">
+              <a:lnSpc>
+                <a:spcPct val="112000"/>
+              </a:lnSpc>
+              <a:spcBef>
+                <a:spcPts val="0"/>
+              </a:spcBef>
+              <a:spcAft>
+                <a:spcPts val="0"/>
+              </a:spcAft>
+            </a:pPr>
+            <a:r>
+              <a:rPr sz="640" b="1" i="0">
+                <a:solidFill>
+                  <a:srgbClr val="059669"/>
+                </a:solidFill>
+                <a:latin typeface="Segoe UI"/>
+                <a:ea typeface="Microsoft YaHei"/>
+              </a:rPr>
+              <a:t>★ </a:t>
+            </a:r>
+            <a:r>
+              <a:rPr sz="640" b="1" i="0">
+                <a:solidFill>
+                  <a:srgbClr val="047857"/>
+                </a:solidFill>
+                <a:latin typeface="Segoe UI"/>
+                <a:ea typeface="Microsoft YaHei"/>
+              </a:rPr>
+              <a:t>Apache Iceberg</a:t>
+            </a:r>
+            <a:r>
+              <a:rPr sz="640" b="0" i="0">
+                <a:solidFill>
+                  <a:srgbClr val="64748B"/>
+                </a:solidFill>
+                <a:latin typeface="Segoe UI"/>
+                <a:ea typeface="Microsoft YaHei"/>
+              </a:rPr>
+              <a:t> 为本项目归档落地格式 · SeaTunnel 可将其作为 Sink 直接写湖</a:t>
             </a:r>
           </a:p>
         </p:txBody>

</xml_diff>